<commit_message>
Style pass: no em dashes, study slide with chart, quantified policy margins, labelled specification, classic coefplot
- New slide 'And the youngest of them leave to study' with a two-panel
  chart (by age at exit, by family situation): 45% of under-30 OLF
  leavers are enrolled in school vs 3% of those with a child at home.
- Policy slide rewritten as three quantified margins (retirees ~3%/yr,
  switchers ~2%/yr, early exits ~2%/yr).
- Specification slide: underbraced mini-names on each vector, plain
  descriptions below, robust SEs and FE structure stated.
- AME coefplot restyled in classic black-and-white econ style (filled =
  significant), enlarged on the slide, footnote removed.
- Trend 'Message' lines added to the evolution, comparability,
  professions, destinations, pay, pension and cycle slides.
- Em dashes removed throughout the deck.

Co-Authored-By: Claude Fable 5 <noreply@anthropic.com>
Claude-Session: https://claude.ai/code/session_01DNzQPDcr3zfLTraMHUHqUn
</commit_message>
<xml_diff>
--- a/report/data_cluster/Proyect_US_cluster.pptx
+++ b/report/data_cluster/Proyect_US_cluster.pptx
@@ -50,6 +50,7 @@
     <p:sldId id="298" r:id="rId50"/>
     <p:sldId id="299" r:id="rId51"/>
     <p:sldId id="300" r:id="rId52"/>
+    <p:sldId id="301" r:id="rId53"/>
   </p:sldIdLst>
   <p:sldSz cx="12191695" cy="6858000" type="screen4x3"/>
   <p:notesSz cx="6858000" cy="9144000"/>
@@ -826,7 +827,7 @@
           <a:lstStyle/>
           <a:p>
             <a:r>
-              <a:t>El grupo que sale antes de los 55: mas de la mitad son madres con un hijo en casa (13 de los 24). El 13 por ciento del grupo estudia, casi todos sin hijos: 25 por ciento de esas mujeres y 48 por ciento de esos hombres, frente al 3 por ciento de las madres.</a:t>
+              <a:t>El grupo que sale antes de los 55: la salida temprana es una historia de familia, mas de la mitad son madres con un hijo en casa (13 de los 24).</a:t>
             </a:r>
           </a:p>
         </p:txBody>
@@ -852,6 +853,76 @@
 </file>
 
 <file path=ppt/notesSlides/notesSlide6.xml><?xml version="1.0" encoding="utf-8"?>
+<p:notes xmlns:a="http://schemas.openxmlformats.org/drawingml/2006/main" xmlns:p="http://schemas.openxmlformats.org/presentationml/2006/main" xmlns:r="http://schemas.openxmlformats.org/officeDocument/2006/relationships">
+  <p:cSld>
+    <p:spTree>
+      <p:nvGrpSpPr>
+        <p:cNvPr id="1" name=""/>
+        <p:cNvGrpSpPr/>
+        <p:nvPr/>
+      </p:nvGrpSpPr>
+      <p:grpSpPr>
+        <a:xfrm>
+          <a:off x="0" y="0"/>
+          <a:ext cx="0" cy="0"/>
+          <a:chOff x="0" y="0"/>
+          <a:chExt cx="0" cy="0"/>
+        </a:xfrm>
+      </p:grpSpPr>
+      <p:sp>
+        <p:nvSpPr>
+          <p:cNvPr id="2" name="Slide Image Placeholder 1"/>
+          <p:cNvSpPr>
+            <a:spLocks noGrp="1"/>
+          </p:cNvSpPr>
+          <p:nvPr>
+            <p:ph type="sldImg" idx="2"/>
+          </p:nvPr>
+        </p:nvSpPr>
+        <p:spPr/>
+      </p:sp>
+      <p:sp>
+        <p:nvSpPr>
+          <p:cNvPr id="3" name="Notes Placeholder 2"/>
+          <p:cNvSpPr>
+            <a:spLocks noGrp="1"/>
+          </p:cNvSpPr>
+          <p:nvPr>
+            <p:ph type="body" idx="3" sz="quarter"/>
+          </p:nvPr>
+        </p:nvSpPr>
+        <p:spPr/>
+        <p:txBody>
+          <a:bodyPr/>
+          <a:lstStyle/>
+          <a:p>
+            <a:r>
+              <a:t>Y los mas jovenes se van a estudiar: entre los que salen de la poblacion activa antes de los 55, estudia el 45 por ciento de los menores de 30 (8 por ciento de 30-39, 3 por ciento de 40-54) y el 31 por ciento de los que no tienen hijos en casa, frente al 3 por ciento de los que si. Ojo: n pequenos, va indicado en cada barra.</a:t>
+            </a:r>
+          </a:p>
+        </p:txBody>
+      </p:sp>
+      <p:sp>
+        <p:nvSpPr>
+          <p:cNvPr id="4" name="Slide Number Placeholder 3"/>
+          <p:cNvSpPr>
+            <a:spLocks noGrp="1"/>
+          </p:cNvSpPr>
+          <p:nvPr>
+            <p:ph type="sldNum" idx="5" sz="quarter"/>
+          </p:nvPr>
+        </p:nvSpPr>
+        <p:spPr/>
+      </p:sp>
+    </p:spTree>
+  </p:cSld>
+  <p:clrMapOvr>
+    <a:masterClrMapping/>
+  </p:clrMapOvr>
+</p:notes>
+</file>
+
+<file path=ppt/notesSlides/notesSlide7.xml><?xml version="1.0" encoding="utf-8"?>
 <p:notes xmlns:a="http://schemas.openxmlformats.org/drawingml/2006/main" xmlns:p="http://schemas.openxmlformats.org/presentationml/2006/main" xmlns:r="http://schemas.openxmlformats.org/officeDocument/2006/relationships">
   <p:cSld>
     <p:spTree>
@@ -4278,7 +4349,7 @@
         </p:nvSpPr>
         <p:spPr>
           <a:xfrm>
-            <a:off x="605225" y="6225232"/>
+            <a:off x="605225" y="6311253"/>
             <a:ext cx="1669633" cy="375321"/>
           </a:xfrm>
           <a:prstGeom prst="rect">
@@ -4406,7 +4477,7 @@
         </p:nvSpPr>
         <p:spPr>
           <a:xfrm>
-            <a:off x="605225" y="6225232"/>
+            <a:off x="605225" y="6311253"/>
             <a:ext cx="1682240" cy="375321"/>
           </a:xfrm>
           <a:prstGeom prst="rect">
@@ -4864,182 +4935,6 @@
           </a:prstGeom>
         </p:spPr>
       </p:pic>
-      <p:sp>
-        <p:nvSpPr>
-          <p:cNvPr id="3" name="Rectangle 2">
-            <a:hlinkClick action="ppaction://hlinksldjump" r:id="rId4"/>
-          </p:cNvPr>
-          <p:cNvSpPr/>
-          <p:nvPr/>
-        </p:nvSpPr>
-        <p:spPr>
-          <a:xfrm>
-            <a:off x="605225" y="4796793"/>
-            <a:ext cx="860192" cy="375321"/>
-          </a:xfrm>
-          <a:prstGeom prst="rect">
-            <a:avLst/>
-          </a:prstGeom>
-          <a:noFill/>
-          <a:ln>
-            <a:noFill/>
-          </a:ln>
-          <a:effectLst/>
-        </p:spPr>
-        <p:style>
-          <a:lnRef idx="1">
-            <a:schemeClr val="accent1"/>
-          </a:lnRef>
-          <a:fillRef idx="3">
-            <a:schemeClr val="accent1"/>
-          </a:fillRef>
-          <a:effectRef idx="2">
-            <a:schemeClr val="accent1"/>
-          </a:effectRef>
-          <a:fontRef idx="minor">
-            <a:schemeClr val="lt1"/>
-          </a:fontRef>
-        </p:style>
-        <p:txBody>
-          <a:bodyPr rtlCol="0" anchor="ctr"/>
-          <a:lstStyle/>
-          <a:p>
-            <a:pPr algn="ctr"/>
-          </a:p>
-        </p:txBody>
-      </p:sp>
-      <p:sp>
-        <p:nvSpPr>
-          <p:cNvPr id="4" name="Rectangle 3">
-            <a:hlinkClick action="ppaction://hlinksldjump" r:id="rId5"/>
-          </p:cNvPr>
-          <p:cNvSpPr/>
-          <p:nvPr/>
-        </p:nvSpPr>
-        <p:spPr>
-          <a:xfrm>
-            <a:off x="1483509" y="4796793"/>
-            <a:ext cx="1439881" cy="375321"/>
-          </a:xfrm>
-          <a:prstGeom prst="rect">
-            <a:avLst/>
-          </a:prstGeom>
-          <a:noFill/>
-          <a:ln>
-            <a:noFill/>
-          </a:ln>
-          <a:effectLst/>
-        </p:spPr>
-        <p:style>
-          <a:lnRef idx="1">
-            <a:schemeClr val="accent1"/>
-          </a:lnRef>
-          <a:fillRef idx="3">
-            <a:schemeClr val="accent1"/>
-          </a:fillRef>
-          <a:effectRef idx="2">
-            <a:schemeClr val="accent1"/>
-          </a:effectRef>
-          <a:fontRef idx="minor">
-            <a:schemeClr val="lt1"/>
-          </a:fontRef>
-        </p:style>
-        <p:txBody>
-          <a:bodyPr rtlCol="0" anchor="ctr"/>
-          <a:lstStyle/>
-          <a:p>
-            <a:pPr algn="ctr"/>
-          </a:p>
-        </p:txBody>
-      </p:sp>
-      <p:sp>
-        <p:nvSpPr>
-          <p:cNvPr id="5" name="Rectangle 4">
-            <a:hlinkClick action="ppaction://hlinksldjump" r:id="rId6"/>
-          </p:cNvPr>
-          <p:cNvSpPr/>
-          <p:nvPr/>
-        </p:nvSpPr>
-        <p:spPr>
-          <a:xfrm>
-            <a:off x="2941481" y="4796793"/>
-            <a:ext cx="1196608" cy="375321"/>
-          </a:xfrm>
-          <a:prstGeom prst="rect">
-            <a:avLst/>
-          </a:prstGeom>
-          <a:noFill/>
-          <a:ln>
-            <a:noFill/>
-          </a:ln>
-          <a:effectLst/>
-        </p:spPr>
-        <p:style>
-          <a:lnRef idx="1">
-            <a:schemeClr val="accent1"/>
-          </a:lnRef>
-          <a:fillRef idx="3">
-            <a:schemeClr val="accent1"/>
-          </a:fillRef>
-          <a:effectRef idx="2">
-            <a:schemeClr val="accent1"/>
-          </a:effectRef>
-          <a:fontRef idx="minor">
-            <a:schemeClr val="lt1"/>
-          </a:fontRef>
-        </p:style>
-        <p:txBody>
-          <a:bodyPr rtlCol="0" anchor="ctr"/>
-          <a:lstStyle/>
-          <a:p>
-            <a:pPr algn="ctr"/>
-          </a:p>
-        </p:txBody>
-      </p:sp>
-      <p:sp>
-        <p:nvSpPr>
-          <p:cNvPr id="6" name="Rectangle 5">
-            <a:hlinkClick action="ppaction://hlinksldjump" r:id="rId7"/>
-          </p:cNvPr>
-          <p:cNvSpPr/>
-          <p:nvPr/>
-        </p:nvSpPr>
-        <p:spPr>
-          <a:xfrm>
-            <a:off x="4156180" y="4796793"/>
-            <a:ext cx="1686944" cy="375321"/>
-          </a:xfrm>
-          <a:prstGeom prst="rect">
-            <a:avLst/>
-          </a:prstGeom>
-          <a:noFill/>
-          <a:ln>
-            <a:noFill/>
-          </a:ln>
-          <a:effectLst/>
-        </p:spPr>
-        <p:style>
-          <a:lnRef idx="1">
-            <a:schemeClr val="accent1"/>
-          </a:lnRef>
-          <a:fillRef idx="3">
-            <a:schemeClr val="accent1"/>
-          </a:fillRef>
-          <a:effectRef idx="2">
-            <a:schemeClr val="accent1"/>
-          </a:effectRef>
-          <a:fontRef idx="minor">
-            <a:schemeClr val="lt1"/>
-          </a:fontRef>
-        </p:style>
-        <p:txBody>
-          <a:bodyPr rtlCol="0" anchor="ctr"/>
-          <a:lstStyle/>
-          <a:p>
-            <a:pPr algn="ctr"/>
-          </a:p>
-        </p:txBody>
-      </p:sp>
     </p:spTree>
   </p:cSld>
   <p:clrMapOvr>
@@ -5082,6 +4977,182 @@
           </a:prstGeom>
         </p:spPr>
       </p:pic>
+      <p:sp>
+        <p:nvSpPr>
+          <p:cNvPr id="3" name="Rectangle 2">
+            <a:hlinkClick action="ppaction://hlinksldjump" r:id="rId4"/>
+          </p:cNvPr>
+          <p:cNvSpPr/>
+          <p:nvPr/>
+        </p:nvSpPr>
+        <p:spPr>
+          <a:xfrm>
+            <a:off x="605225" y="5851119"/>
+            <a:ext cx="860192" cy="375348"/>
+          </a:xfrm>
+          <a:prstGeom prst="rect">
+            <a:avLst/>
+          </a:prstGeom>
+          <a:noFill/>
+          <a:ln>
+            <a:noFill/>
+          </a:ln>
+          <a:effectLst/>
+        </p:spPr>
+        <p:style>
+          <a:lnRef idx="1">
+            <a:schemeClr val="accent1"/>
+          </a:lnRef>
+          <a:fillRef idx="3">
+            <a:schemeClr val="accent1"/>
+          </a:fillRef>
+          <a:effectRef idx="2">
+            <a:schemeClr val="accent1"/>
+          </a:effectRef>
+          <a:fontRef idx="minor">
+            <a:schemeClr val="lt1"/>
+          </a:fontRef>
+        </p:style>
+        <p:txBody>
+          <a:bodyPr rtlCol="0" anchor="ctr"/>
+          <a:lstStyle/>
+          <a:p>
+            <a:pPr algn="ctr"/>
+          </a:p>
+        </p:txBody>
+      </p:sp>
+      <p:sp>
+        <p:nvSpPr>
+          <p:cNvPr id="4" name="Rectangle 3">
+            <a:hlinkClick action="ppaction://hlinksldjump" r:id="rId5"/>
+          </p:cNvPr>
+          <p:cNvSpPr/>
+          <p:nvPr/>
+        </p:nvSpPr>
+        <p:spPr>
+          <a:xfrm>
+            <a:off x="1483509" y="5851119"/>
+            <a:ext cx="1439881" cy="375348"/>
+          </a:xfrm>
+          <a:prstGeom prst="rect">
+            <a:avLst/>
+          </a:prstGeom>
+          <a:noFill/>
+          <a:ln>
+            <a:noFill/>
+          </a:ln>
+          <a:effectLst/>
+        </p:spPr>
+        <p:style>
+          <a:lnRef idx="1">
+            <a:schemeClr val="accent1"/>
+          </a:lnRef>
+          <a:fillRef idx="3">
+            <a:schemeClr val="accent1"/>
+          </a:fillRef>
+          <a:effectRef idx="2">
+            <a:schemeClr val="accent1"/>
+          </a:effectRef>
+          <a:fontRef idx="minor">
+            <a:schemeClr val="lt1"/>
+          </a:fontRef>
+        </p:style>
+        <p:txBody>
+          <a:bodyPr rtlCol="0" anchor="ctr"/>
+          <a:lstStyle/>
+          <a:p>
+            <a:pPr algn="ctr"/>
+          </a:p>
+        </p:txBody>
+      </p:sp>
+      <p:sp>
+        <p:nvSpPr>
+          <p:cNvPr id="5" name="Rectangle 4">
+            <a:hlinkClick action="ppaction://hlinksldjump" r:id="rId6"/>
+          </p:cNvPr>
+          <p:cNvSpPr/>
+          <p:nvPr/>
+        </p:nvSpPr>
+        <p:spPr>
+          <a:xfrm>
+            <a:off x="2941481" y="5851119"/>
+            <a:ext cx="1196608" cy="375348"/>
+          </a:xfrm>
+          <a:prstGeom prst="rect">
+            <a:avLst/>
+          </a:prstGeom>
+          <a:noFill/>
+          <a:ln>
+            <a:noFill/>
+          </a:ln>
+          <a:effectLst/>
+        </p:spPr>
+        <p:style>
+          <a:lnRef idx="1">
+            <a:schemeClr val="accent1"/>
+          </a:lnRef>
+          <a:fillRef idx="3">
+            <a:schemeClr val="accent1"/>
+          </a:fillRef>
+          <a:effectRef idx="2">
+            <a:schemeClr val="accent1"/>
+          </a:effectRef>
+          <a:fontRef idx="minor">
+            <a:schemeClr val="lt1"/>
+          </a:fontRef>
+        </p:style>
+        <p:txBody>
+          <a:bodyPr rtlCol="0" anchor="ctr"/>
+          <a:lstStyle/>
+          <a:p>
+            <a:pPr algn="ctr"/>
+          </a:p>
+        </p:txBody>
+      </p:sp>
+      <p:sp>
+        <p:nvSpPr>
+          <p:cNvPr id="6" name="Rectangle 5">
+            <a:hlinkClick action="ppaction://hlinksldjump" r:id="rId7"/>
+          </p:cNvPr>
+          <p:cNvSpPr/>
+          <p:nvPr/>
+        </p:nvSpPr>
+        <p:spPr>
+          <a:xfrm>
+            <a:off x="4156180" y="5851119"/>
+            <a:ext cx="1686944" cy="375348"/>
+          </a:xfrm>
+          <a:prstGeom prst="rect">
+            <a:avLst/>
+          </a:prstGeom>
+          <a:noFill/>
+          <a:ln>
+            <a:noFill/>
+          </a:ln>
+          <a:effectLst/>
+        </p:spPr>
+        <p:style>
+          <a:lnRef idx="1">
+            <a:schemeClr val="accent1"/>
+          </a:lnRef>
+          <a:fillRef idx="3">
+            <a:schemeClr val="accent1"/>
+          </a:fillRef>
+          <a:effectRef idx="2">
+            <a:schemeClr val="accent1"/>
+          </a:effectRef>
+          <a:fontRef idx="minor">
+            <a:schemeClr val="lt1"/>
+          </a:fontRef>
+        </p:style>
+        <p:txBody>
+          <a:bodyPr rtlCol="0" anchor="ctr"/>
+          <a:lstStyle/>
+          <a:p>
+            <a:pPr algn="ctr"/>
+          </a:p>
+        </p:txBody>
+      </p:sp>
     </p:spTree>
   </p:cSld>
   <p:clrMapOvr>
@@ -5418,50 +5489,6 @@
           </a:prstGeom>
         </p:spPr>
       </p:pic>
-      <p:sp>
-        <p:nvSpPr>
-          <p:cNvPr id="3" name="Rectangle 2">
-            <a:hlinkClick action="ppaction://hlinksldjump" r:id="rId3"/>
-          </p:cNvPr>
-          <p:cNvSpPr/>
-          <p:nvPr/>
-        </p:nvSpPr>
-        <p:spPr>
-          <a:xfrm>
-            <a:off x="10747754" y="6415097"/>
-            <a:ext cx="838714" cy="375348"/>
-          </a:xfrm>
-          <a:prstGeom prst="rect">
-            <a:avLst/>
-          </a:prstGeom>
-          <a:noFill/>
-          <a:ln>
-            <a:noFill/>
-          </a:ln>
-          <a:effectLst/>
-        </p:spPr>
-        <p:style>
-          <a:lnRef idx="1">
-            <a:schemeClr val="accent1"/>
-          </a:lnRef>
-          <a:fillRef idx="3">
-            <a:schemeClr val="accent1"/>
-          </a:fillRef>
-          <a:effectRef idx="2">
-            <a:schemeClr val="accent1"/>
-          </a:effectRef>
-          <a:fontRef idx="minor">
-            <a:schemeClr val="lt1"/>
-          </a:fontRef>
-        </p:style>
-        <p:txBody>
-          <a:bodyPr rtlCol="0" anchor="ctr"/>
-          <a:lstStyle/>
-          <a:p>
-            <a:pPr algn="ctr"/>
-          </a:p>
-        </p:txBody>
-      </p:sp>
     </p:spTree>
   </p:cSld>
   <p:clrMapOvr>
@@ -5514,8 +5541,8 @@
         </p:nvSpPr>
         <p:spPr>
           <a:xfrm>
-            <a:off x="10747754" y="5686146"/>
-            <a:ext cx="838714" cy="375321"/>
+            <a:off x="10747754" y="6415097"/>
+            <a:ext cx="838714" cy="375348"/>
           </a:xfrm>
           <a:prstGeom prst="rect">
             <a:avLst/>
@@ -5600,8 +5627,8 @@
         </p:nvSpPr>
         <p:spPr>
           <a:xfrm>
-            <a:off x="10747754" y="5398674"/>
-            <a:ext cx="838714" cy="375348"/>
+            <a:off x="10747754" y="5686146"/>
+            <a:ext cx="838714" cy="375321"/>
           </a:xfrm>
           <a:prstGeom prst="rect">
             <a:avLst/>
@@ -5686,8 +5713,8 @@
         </p:nvSpPr>
         <p:spPr>
           <a:xfrm>
-            <a:off x="10747754" y="6244076"/>
-            <a:ext cx="838714" cy="375321"/>
+            <a:off x="10747754" y="5398674"/>
+            <a:ext cx="838714" cy="375348"/>
           </a:xfrm>
           <a:prstGeom prst="rect">
             <a:avLst/>
@@ -5772,7 +5799,7 @@
         </p:nvSpPr>
         <p:spPr>
           <a:xfrm>
-            <a:off x="10747754" y="5731415"/>
+            <a:off x="10747754" y="6244076"/>
             <a:ext cx="838714" cy="375321"/>
           </a:xfrm>
           <a:prstGeom prst="rect">
@@ -5858,7 +5885,7 @@
         </p:nvSpPr>
         <p:spPr>
           <a:xfrm>
-            <a:off x="10747754" y="6244076"/>
+            <a:off x="10747754" y="5731415"/>
             <a:ext cx="838714" cy="375321"/>
           </a:xfrm>
           <a:prstGeom prst="rect">
@@ -6244,8 +6271,8 @@
         </p:nvSpPr>
         <p:spPr>
           <a:xfrm>
-            <a:off x="10747754" y="5626147"/>
-            <a:ext cx="838714" cy="375348"/>
+            <a:off x="10747754" y="6244076"/>
+            <a:ext cx="838714" cy="375321"/>
           </a:xfrm>
           <a:prstGeom prst="rect">
             <a:avLst/>
@@ -6330,8 +6357,8 @@
         </p:nvSpPr>
         <p:spPr>
           <a:xfrm>
-            <a:off x="10747754" y="6244076"/>
-            <a:ext cx="838714" cy="375321"/>
+            <a:off x="10747754" y="5626147"/>
+            <a:ext cx="838714" cy="375348"/>
           </a:xfrm>
           <a:prstGeom prst="rect">
             <a:avLst/>
@@ -6416,7 +6443,7 @@
         </p:nvSpPr>
         <p:spPr>
           <a:xfrm>
-            <a:off x="10747754" y="5574346"/>
+            <a:off x="10747754" y="6244076"/>
             <a:ext cx="838714" cy="375321"/>
           </a:xfrm>
           <a:prstGeom prst="rect">
@@ -6588,7 +6615,7 @@
         </p:nvSpPr>
         <p:spPr>
           <a:xfrm>
-            <a:off x="10747754" y="6268431"/>
+            <a:off x="10747754" y="5574346"/>
             <a:ext cx="838714" cy="375321"/>
           </a:xfrm>
           <a:prstGeom prst="rect">
@@ -6643,6 +6670,92 @@
       <p:pic>
         <p:nvPicPr>
           <p:cNvPr id="2" name="Picture 1" descr="pg-45.png"/>
+          <p:cNvPicPr>
+            <a:picLocks noChangeAspect="1"/>
+          </p:cNvPicPr>
+          <p:nvPr/>
+        </p:nvPicPr>
+        <p:blipFill>
+          <a:blip r:embed="rId2"/>
+          <a:stretch>
+            <a:fillRect/>
+          </a:stretch>
+        </p:blipFill>
+        <p:spPr>
+          <a:xfrm>
+            <a:off x="0" y="0"/>
+            <a:ext cx="12191695" cy="6858000"/>
+          </a:xfrm>
+          <a:prstGeom prst="rect">
+            <a:avLst/>
+          </a:prstGeom>
+        </p:spPr>
+      </p:pic>
+      <p:sp>
+        <p:nvSpPr>
+          <p:cNvPr id="3" name="Rectangle 2">
+            <a:hlinkClick action="ppaction://hlinksldjump" r:id="rId3"/>
+          </p:cNvPr>
+          <p:cNvSpPr/>
+          <p:nvPr/>
+        </p:nvSpPr>
+        <p:spPr>
+          <a:xfrm>
+            <a:off x="10747754" y="6268431"/>
+            <a:ext cx="838714" cy="375321"/>
+          </a:xfrm>
+          <a:prstGeom prst="rect">
+            <a:avLst/>
+          </a:prstGeom>
+          <a:noFill/>
+          <a:ln>
+            <a:noFill/>
+          </a:ln>
+          <a:effectLst/>
+        </p:spPr>
+        <p:style>
+          <a:lnRef idx="1">
+            <a:schemeClr val="accent1"/>
+          </a:lnRef>
+          <a:fillRef idx="3">
+            <a:schemeClr val="accent1"/>
+          </a:fillRef>
+          <a:effectRef idx="2">
+            <a:schemeClr val="accent1"/>
+          </a:effectRef>
+          <a:fontRef idx="minor">
+            <a:schemeClr val="lt1"/>
+          </a:fontRef>
+        </p:style>
+        <p:txBody>
+          <a:bodyPr rtlCol="0" anchor="ctr"/>
+          <a:lstStyle/>
+          <a:p>
+            <a:pPr algn="ctr"/>
+          </a:p>
+        </p:txBody>
+      </p:sp>
+    </p:spTree>
+  </p:cSld>
+  <p:clrMapOvr>
+    <a:masterClrMapping/>
+  </p:clrMapOvr>
+</p:sld>
+</file>
+
+<file path=ppt/slides/slide46.xml><?xml version="1.0" encoding="utf-8"?>
+<p:sld xmlns:a="http://schemas.openxmlformats.org/drawingml/2006/main" xmlns:p="http://schemas.openxmlformats.org/presentationml/2006/main" xmlns:r="http://schemas.openxmlformats.org/officeDocument/2006/relationships">
+  <p:cSld>
+    <p:spTree>
+      <p:nvGrpSpPr>
+        <p:cNvPr id="1" name=""/>
+        <p:cNvGrpSpPr/>
+        <p:nvPr/>
+      </p:nvGrpSpPr>
+      <p:grpSpPr/>
+      <p:pic>
+        <p:nvPicPr>
+          <p:cNvPr id="2" name="Picture 1" descr="pg-46.png"/>
           <p:cNvPicPr>
             <a:picLocks noChangeAspect="1"/>
           </p:cNvPicPr>

</xml_diff>

<commit_message>
Harmonize teacher series across charts; conclusions rewritten with age point
- The professions chart pooled 3-year windows while the evolution chart
  was raw annual, so the same teacher series looked different (7.9 vs
  7.7 endpoint). The professions chart now plots raw annual rates for
  all four professions; the teacher line matches g2_evolution point by
  point. Y-axis raised to 20 so social workers' noisier raw series is
  not clipped; the 9-profession appendix keeps its 3-year moving
  averages and now says so on the slide in both decks.
- 'Conclusions: what we learn' replaced with the author's three bullets
  (grammar-fixed) plus a fourth on age beyond working conditions.

Co-Authored-By: Claude Fable 5 <noreply@anthropic.com>
Claude-Session: https://claude.ai/code/session_01DNzQPDcr3zfLTraMHUHqUn
</commit_message>
<xml_diff>
--- a/report/data_cluster/Proyect_US_cluster.pptx
+++ b/report/data_cluster/Proyect_US_cluster.pptx
@@ -12222,7 +12222,7 @@
         </p:nvSpPr>
         <p:spPr>
           <a:xfrm>
-            <a:off x="822960" y="1417320"/>
+            <a:off x="822960" y="1325880"/>
             <a:ext cx="10789920" cy="5120640"/>
           </a:xfrm>
           <a:prstGeom prst="rect">
@@ -12241,7 +12241,7 @@
                 <a:spcPts val="2432"/>
               </a:lnSpc>
               <a:spcAft>
-                <a:spcPts val="2600"/>
+                <a:spcPts val="2400"/>
               </a:spcAft>
             </a:pPr>
             <a:r>
@@ -12260,7 +12260,7 @@
                 </a:solidFill>
                 <a:latin typeface="Garamond"/>
               </a:rPr>
-              <a:t>Teacher attrition is not bad in itself. Much of it reflects an active labor market, and it moves with the general cycle. The question for policy is who leaves, and why.</a:t>
+              <a:t>Job security is fundamental to retain a teacher. Our analysis shows that a full-year contract and pension coverage are strongly correlated with a lower leaving rate.</a:t>
             </a:r>
           </a:p>
           <a:p>
@@ -12269,7 +12269,7 @@
                 <a:spcPts val="2432"/>
               </a:lnSpc>
               <a:spcAft>
-                <a:spcPts val="2600"/>
+                <a:spcPts val="2400"/>
               </a:spcAft>
             </a:pPr>
             <a:r>
@@ -12288,7 +12288,7 @@
                 </a:solidFill>
                 <a:latin typeface="Garamond"/>
               </a:rPr>
-              <a:t>Working conditions weigh heavily. A full-year contract is the single strongest protection against leaving, so job security is fundamental to retain a teacher.</a:t>
+              <a:t>The financial margin still has room as a retention incentive in the US. Most leavers concentrate in the bottom deciles of income.</a:t>
             </a:r>
           </a:p>
           <a:p>
@@ -12297,7 +12297,7 @@
                 <a:spcPts val="2432"/>
               </a:lnSpc>
               <a:spcAft>
-                <a:spcPts val="2600"/>
+                <a:spcPts val="2400"/>
               </a:spcAft>
             </a:pPr>
             <a:r>
@@ -12316,7 +12316,7 @@
                 </a:solidFill>
                 <a:latin typeface="Garamond"/>
               </a:rPr>
-              <a:t>Not everyone who leaves earns more afterwards, and leaving concentrates at the bottom of the pay scale. The financial lever still has room as a retention incentive.</a:t>
+              <a:t>A quarter of exits are neither another job nor retirement but care at home or further study. Flexibility can ease the return of part of that group, and additional qualifications should pay when they return.</a:t>
             </a:r>
           </a:p>
           <a:p>
@@ -12344,7 +12344,7 @@
                 </a:solidFill>
                 <a:latin typeface="Garamond"/>
               </a:rPr>
-              <a:t>A quarter of exits are neither another job nor retirement but care at home or further study. Flexibility can bring that group back, and additional qualifications should pay when they return.</a:t>
+              <a:t>Age matters beyond working conditions. The risk of leaving follows the life cycle and is highest at the two ends of a career: the young leave for other jobs or further study, the old retire. Early-career mentoring is where prevention pays the most.</a:t>
             </a:r>
           </a:p>
         </p:txBody>
@@ -17505,8 +17505,8 @@
         </p:blipFill>
         <p:spPr>
           <a:xfrm>
-            <a:off x="1297304" y="1097280"/>
-            <a:ext cx="9566910" cy="4937760"/>
+            <a:off x="1563052" y="1097280"/>
+            <a:ext cx="9035415" cy="4663440"/>
           </a:xfrm>
           <a:prstGeom prst="rect">
             <a:avLst/>
@@ -17515,7 +17515,49 @@
       </p:pic>
       <p:sp>
         <p:nvSpPr>
-          <p:cNvPr id="5" name="Rounded Rectangle 4">
+          <p:cNvPr id="5" name="TextBox 4"/>
+          <p:cNvSpPr txBox="1"/>
+          <p:nvPr/>
+        </p:nvSpPr>
+        <p:spPr>
+          <a:xfrm>
+            <a:off x="822960" y="5897880"/>
+            <a:ext cx="10789920" cy="365760"/>
+          </a:xfrm>
+          <a:prstGeom prst="rect">
+            <a:avLst/>
+          </a:prstGeom>
+          <a:noFill/>
+        </p:spPr>
+        <p:txBody>
+          <a:bodyPr wrap="square" lIns="0" rIns="0" tIns="0" bIns="0">
+            <a:spAutoFit/>
+          </a:bodyPr>
+          <a:lstStyle/>
+          <a:p>
+            <a:pPr algn="l">
+              <a:lnSpc>
+                <a:spcPts val="1600"/>
+              </a:lnSpc>
+              <a:spcAft>
+                <a:spcPts val="0"/>
+              </a:spcAft>
+            </a:pPr>
+            <a:r>
+              <a:rPr sz="1250" b="0" i="1">
+                <a:solidFill>
+                  <a:srgbClr val="6B7480"/>
+                </a:solidFill>
+                <a:latin typeface="Garamond"/>
+              </a:rPr>
+              <a:t>Three-year moving averages, for readability with nine professions. The main charts use the raw annual series.</a:t>
+            </a:r>
+          </a:p>
+        </p:txBody>
+      </p:sp>
+      <p:sp>
+        <p:nvSpPr>
+          <p:cNvPr id="6" name="Rounded Rectangle 5">
             <a:hlinkClick action="ppaction://hlinksldjump" r:id="rId3"/>
           </p:cNvPr>
           <p:cNvSpPr/>

</xml_diff>

<commit_message>
Final conclusions wording from the author, with the early-career closing line
Co-Authored-By: Claude Fable 5 <noreply@anthropic.com>
Claude-Session: https://claude.ai/code/session_01DNzQPDcr3zfLTraMHUHqUn
</commit_message>
<xml_diff>
--- a/report/data_cluster/Proyect_US_cluster.pptx
+++ b/report/data_cluster/Proyect_US_cluster.pptx
@@ -12260,7 +12260,7 @@
                 </a:solidFill>
                 <a:latin typeface="Garamond"/>
               </a:rPr>
-              <a:t>Job security is fundamental to retain a teacher. Our analysis shows that a full-year contract and pension coverage are strongly correlated with a lower leaving rate.</a:t>
+              <a:t>Job security is fundamental to retain a teacher, our analysis shows that a full-year contract and pension coverage are strongly correlated with a lower teacher leaving rate.</a:t>
             </a:r>
           </a:p>
           <a:p>
@@ -12288,7 +12288,7 @@
                 </a:solidFill>
                 <a:latin typeface="Garamond"/>
               </a:rPr>
-              <a:t>The financial margin still has room as a retention incentive in the US. Most leavers concentrate in the bottom deciles of income.</a:t>
+              <a:t>The financial margin still has room as a retention incentive in the US as most leavers concentrate in the bottom deciles of income.</a:t>
             </a:r>
           </a:p>
           <a:p>
@@ -12316,7 +12316,7 @@
                 </a:solidFill>
                 <a:latin typeface="Garamond"/>
               </a:rPr>
-              <a:t>A quarter of exits are neither another job nor retirement but care at home or further study. Flexibility can ease the return of part of that group, and additional qualifications should pay when they return.</a:t>
+              <a:t>The most important group of teachers that leave without moving to another job are mothers with a child at home, followed by the young who go back to study. Flexibility can ease the return of that group, and additional qualifications should pay when they come back.</a:t>
             </a:r>
           </a:p>
           <a:p>
@@ -12344,7 +12344,7 @@
                 </a:solidFill>
                 <a:latin typeface="Garamond"/>
               </a:rPr>
-              <a:t>Age matters beyond working conditions. The risk of leaving follows the life cycle and is highest at the two ends of a career: the young leave for other jobs or further study, the old retire. Early-career mentoring is where prevention pays the most.</a:t>
+              <a:t>Age matters beyond working conditions, the risk of leaving follows the life cycle and peaks at the two ends of a career. Therefore, early-career retention efforts are key (e.g. mentorship, balanced working conditions, secure placements).</a:t>
             </a:r>
           </a:p>
         </p:txBody>

</xml_diff>

<commit_message>
Conclusions set to the author's final three bullets
Co-Authored-By: Claude Fable 5 <noreply@anthropic.com>
Claude-Session: https://claude.ai/code/session_01DNzQPDcr3zfLTraMHUHqUn
</commit_message>
<xml_diff>
--- a/report/data_cluster/Proyect_US_cluster.pptx
+++ b/report/data_cluster/Proyect_US_cluster.pptx
@@ -12222,7 +12222,7 @@
         </p:nvSpPr>
         <p:spPr>
           <a:xfrm>
-            <a:off x="822960" y="1325880"/>
+            <a:off x="822960" y="1417320"/>
             <a:ext cx="10789920" cy="5120640"/>
           </a:xfrm>
           <a:prstGeom prst="rect">
@@ -12241,7 +12241,7 @@
                 <a:spcPts val="2432"/>
               </a:lnSpc>
               <a:spcAft>
-                <a:spcPts val="2400"/>
+                <a:spcPts val="3000"/>
               </a:spcAft>
             </a:pPr>
             <a:r>
@@ -12269,7 +12269,7 @@
                 <a:spcPts val="2432"/>
               </a:lnSpc>
               <a:spcAft>
-                <a:spcPts val="2400"/>
+                <a:spcPts val="3000"/>
               </a:spcAft>
             </a:pPr>
             <a:r>
@@ -12288,7 +12288,7 @@
                 </a:solidFill>
                 <a:latin typeface="Garamond"/>
               </a:rPr>
-              <a:t>The financial margin still has room as a retention incentive in the US as most leavers concentrate in the bottom deciles of income.</a:t>
+              <a:t>Most leavers concentrate in the bottom deciles of income and the ones that switch jobs do not necessarily earn more, suggesting that on top of better working conditions the financial margin still has room as a retention incentive in the US.</a:t>
             </a:r>
           </a:p>
           <a:p>
@@ -12297,7 +12297,7 @@
                 <a:spcPts val="2432"/>
               </a:lnSpc>
               <a:spcAft>
-                <a:spcPts val="2400"/>
+                <a:spcPts val="0"/>
               </a:spcAft>
             </a:pPr>
             <a:r>
@@ -12316,35 +12316,7 @@
                 </a:solidFill>
                 <a:latin typeface="Garamond"/>
               </a:rPr>
-              <a:t>The most important group of teachers that leave without moving to another job are mothers with a child at home, followed by the young who go back to study. Flexibility can ease the return of that group, and additional qualifications should pay when they come back.</a:t>
-            </a:r>
-          </a:p>
-          <a:p>
-            <a:pPr algn="l">
-              <a:lnSpc>
-                <a:spcPts val="2432"/>
-              </a:lnSpc>
-              <a:spcAft>
-                <a:spcPts val="0"/>
-              </a:spcAft>
-            </a:pPr>
-            <a:r>
-              <a:rPr sz="1900" b="1" i="0">
-                <a:solidFill>
-                  <a:srgbClr val="2D6CB5"/>
-                </a:solidFill>
-                <a:latin typeface="Garamond"/>
-              </a:rPr>
-              <a:t>▪  </a:t>
-            </a:r>
-            <a:r>
-              <a:rPr sz="1900" b="0" i="0">
-                <a:solidFill>
-                  <a:srgbClr val="212529"/>
-                </a:solidFill>
-                <a:latin typeface="Garamond"/>
-              </a:rPr>
-              <a:t>Age matters beyond working conditions, the risk of leaving follows the life cycle and peaks at the two ends of a career. Therefore, early-career retention efforts are key (e.g. mentorship, balanced working conditions, secure placements).</a:t>
+              <a:t>The probability of leaving is highest at the start of the career, making mentoring and accompaniment a priority for retention policies.</a:t>
             </a:r>
           </a:p>
         </p:txBody>

</xml_diff>

<commit_message>
Replace Accountants with Counselors as the third comparator
- Searched candidate professions on the pooled 2015-2024 observables:
  counselors match teachers on gender (76.2 vs 76.0) and median pay
  (55k vs 56k) with a healthy sample (3,962); librarians are closest
  overall but tiny (n=788) and school-adjacent; accountants were the
  most distant candidate.
- Swapped in the comparability table, the professions leaving chart
  (1990 code 163, 2010 code 2000, 2018 codes 2001-2006) and the
  relative-pay panel; pay_prof_medians.csv rebuilt with the replicated
  methodology (BA+, full-year full-time, 25-64, CPI-deflated medians)
  plus a Counselors column.
- Counselors' real pay fell 10% since 1997, so the pay message now
  reads: stagnation is shared by the helping professions while the
  typical graduate out-earns a teacher by USD 30,000.

Co-Authored-By: Claude Fable 5 <noreply@anthropic.com>
Claude-Session: https://claude.ai/code/session_01DNzQPDcr3zfLTraMHUHqUn
</commit_message>
<xml_diff>
--- a/report/data_cluster/Proyect_US_cluster.pptx
+++ b/report/data_cluster/Proyect_US_cluster.pptx
@@ -6764,7 +6764,7 @@
                 </a:solidFill>
                 <a:latin typeface="Garamond"/>
               </a:rPr>
-              <a:t>Accountants</a:t>
+              <a:t>Counselors</a:t>
             </a:r>
           </a:p>
         </p:txBody>
@@ -7010,7 +7010,7 @@
                 </a:solidFill>
                 <a:latin typeface="Garamond"/>
               </a:rPr>
-              <a:t>57.0</a:t>
+              <a:t>76.2</a:t>
             </a:r>
           </a:p>
         </p:txBody>
@@ -7220,7 +7220,7 @@
                 </a:solidFill>
                 <a:latin typeface="Garamond"/>
               </a:rPr>
-              <a:t>44.1</a:t>
+              <a:t>43.2</a:t>
             </a:r>
           </a:p>
         </p:txBody>
@@ -7430,7 +7430,7 @@
                 </a:solidFill>
                 <a:latin typeface="Garamond"/>
               </a:rPr>
-              <a:t>31.3</a:t>
+              <a:t>67.8</a:t>
             </a:r>
           </a:p>
         </p:txBody>
@@ -7640,7 +7640,7 @@
                 </a:solidFill>
                 <a:latin typeface="Garamond"/>
               </a:rPr>
-              <a:t>11.0</a:t>
+              <a:t>36.7</a:t>
             </a:r>
           </a:p>
         </p:txBody>
@@ -7850,7 +7850,7 @@
                 </a:solidFill>
                 <a:latin typeface="Garamond"/>
               </a:rPr>
-              <a:t>49.5</a:t>
+              <a:t>48.5</a:t>
             </a:r>
           </a:p>
         </p:txBody>
@@ -8060,7 +8060,7 @@
                 </a:solidFill>
                 <a:latin typeface="Garamond"/>
               </a:rPr>
-              <a:t>77,000</a:t>
+              <a:t>55,000</a:t>
             </a:r>
           </a:p>
         </p:txBody>
@@ -8306,7 +8306,7 @@
                 </a:solidFill>
                 <a:latin typeface="Garamond"/>
               </a:rPr>
-              <a:t>6,897</a:t>
+              <a:t>3,962</a:t>
             </a:r>
           </a:p>
         </p:txBody>
@@ -8435,7 +8435,7 @@
                 </a:solidFill>
                 <a:latin typeface="Garamond"/>
               </a:rPr>
-              <a:t>Teaching is similar to nursing and social work in age and gender, and to social work in education. It differs in pay, weeks worked and the public sector.</a:t>
+              <a:t>Teaching is similar to counseling in gender and pay, and to social work in age and education. What sets teaching apart is the public sector and the shorter work year.</a:t>
             </a:r>
           </a:p>
         </p:txBody>
@@ -8595,7 +8595,7 @@
                 </a:solidFill>
                 <a:latin typeface="Garamond"/>
               </a:rPr>
-              <a:t>Teachers leave at about the same rate as comparable professions. The distinctive part of teaching is who leaves and where they go, not how many.</a:t>
+              <a:t>Teachers leave at rates similar to or below the comparable professions. The distinctive part of teaching is who leaves and where they go, not how many.</a:t>
             </a:r>
           </a:p>
         </p:txBody>
@@ -11439,7 +11439,7 @@
                 </a:solidFill>
                 <a:latin typeface="Garamond"/>
               </a:rPr>
-              <a:t>Teacher pay has not grown in 25 years. Teachers sit 4% below their 1997 level, while comparable professions grew by about 12% on average.</a:t>
+              <a:t>Teacher pay has not grown in 25 years, and neither has it in the closest helping professions. The typical graduate now out-earns a teacher by $30,000 a year.</a:t>
             </a:r>
           </a:p>
         </p:txBody>

</xml_diff>

<commit_message>
Study chart redesigned: grouped bars with the graduate benchmark
Share enrolled in school among teacher leavers out of the labor force,
by age at exit, against all college graduates out of the labor force in
the same ASEC files (under 30: 45 vs 60; 30-39: 8 vs 11; 40-54: 3 vs 4).

Co-Authored-By: Claude Fable 5 <noreply@anthropic.com>
Claude-Session: https://claude.ai/code/session_01DNzQPDcr3zfLTraMHUHqUn
</commit_message>
<xml_diff>
--- a/report/data_cluster/Proyect_US_cluster.pptx
+++ b/report/data_cluster/Proyect_US_cluster.pptx
@@ -9910,8 +9910,8 @@
         </p:blipFill>
         <p:spPr>
           <a:xfrm>
-            <a:off x="1357685" y="1051560"/>
-            <a:ext cx="9446149" cy="4526280"/>
+            <a:off x="1184987" y="1051560"/>
+            <a:ext cx="9791544" cy="4526280"/>
           </a:xfrm>
           <a:prstGeom prst="rect">
             <a:avLst/>
@@ -9964,7 +9964,7 @@
                 </a:solidFill>
                 <a:latin typeface="Garamond"/>
               </a:rPr>
-              <a:t>Studying is the exit of the young and the childless, not of the mothers. Among leavers under 30, almost half are enrolled in school.</a:t>
+              <a:t>Leaving to study follows age, and teacher leavers mirror the typical graduate out of the labor force: 45% of those under 30 are enrolled in school, next to 60% among all graduates. After 40, almost none study.</a:t>
             </a:r>
           </a:p>
         </p:txBody>

</xml_diff>

<commit_message>
Pooled flow extended to 1997-2024 with 1990-code destination mapping; cascade in percentages; notebook pins the branch
Co-Authored-By: Claude Fable 5 <noreply@anthropic.com>
Claude-Session: https://claude.ai/code/session_01DNzQPDcr3zfLTraMHUHqUn
</commit_message>
<xml_diff>
--- a/report/data_cluster/Proyect_US_cluster.pptx
+++ b/report/data_cluster/Proyect_US_cluster.pptx
@@ -9094,7 +9094,7 @@
                 </a:solidFill>
                 <a:latin typeface="Garamond"/>
               </a:rPr>
-              <a:t>Pooled 2002–24</a:t>
+              <a:t>Pooled 1997–24</a:t>
             </a:r>
           </a:p>
         </p:txBody>
@@ -19244,7 +19244,7 @@
                 </a:solidFill>
                 <a:latin typeface="Garamond"/>
               </a:rPr>
-              <a:t>The same flow, pooled 2002–2024</a:t>
+              <a:t>The same flow, pooled 1997–2024</a:t>
             </a:r>
           </a:p>
         </p:txBody>
@@ -19345,7 +19345,7 @@
                 </a:solidFill>
                 <a:latin typeface="Garamond"/>
               </a:rPr>
-              <a:t>Over the whole comparable-codes period (5,791 leavers) the composition barely moves: 26 to another job, 35 retired, 27 out of the labor force before 55 and 12 unemployed; the employed split is 22 / 9 / 30 / 39 percent. The five-year window is not driving the picture.</a:t>
+              <a:t>Over the whole period 1997–2024 (6,866 leavers, destination groups mapped across the 1990 and 2002/2010/2018 classifications) the composition barely moves: 27 to another job, 33 retired, 28 out of the labor force before 55 and 12 unemployed; the employed split is 22 / 8 / 30 / 40 percent. The five-year window is not driving the picture.</a:t>
             </a:r>
           </a:p>
         </p:txBody>

</xml_diff>

<commit_message>
Redo codes slide as two-bullet text: Who counts as a teacher?
Replace the three-regime code-mapping diagram with plain text in both
decks: how the census classifies occupations, the five categories we
count as teachers, and the 0.1-point robustness of the pooled leaving
rate to dropping special education and other teachers. Ship the
standalone whoisteacher_slide.pptx with the Traceability button.

Co-Authored-By: Claude Fable 5 <noreply@anthropic.com>
Claude-Session: https://claude.ai/code/session_01DNzQPDcr3zfLTraMHUHqUn
</commit_message>
<xml_diff>
--- a/report/data_cluster/Proyect_US_cluster.pptx
+++ b/report/data_cluster/Proyect_US_cluster.pptx
@@ -28796,7 +28796,7 @@
                 </a:solidFill>
                 <a:latin typeface="Garamond"/>
               </a:rPr>
-              <a:t>One teacher group, three coding regimes</a:t>
+              <a:t>Who counts as a teacher?</a:t>
             </a:r>
           </a:p>
         </p:txBody>
@@ -28844,36 +28844,45 @@
         </p:nvSpPr>
         <p:spPr>
           <a:xfrm>
-            <a:off x="4663440" y="1417320"/>
-            <a:ext cx="1737360" cy="365760"/>
-          </a:xfrm>
-          <a:prstGeom prst="rect">
-            <a:avLst/>
-          </a:prstGeom>
-          <a:noFill/>
-        </p:spPr>
-        <p:txBody>
-          <a:bodyPr wrap="square" lIns="0" rIns="0" tIns="0" bIns="0">
-            <a:spAutoFit/>
-          </a:bodyPr>
-          <a:lstStyle/>
-          <a:p>
-            <a:pPr algn="ctr">
-              <a:lnSpc>
-                <a:spcPts val="2048"/>
-              </a:lnSpc>
-              <a:spcAft>
-                <a:spcPts val="0"/>
-              </a:spcAft>
-            </a:pPr>
-            <a:r>
-              <a:rPr sz="1600" b="0" i="0">
-                <a:solidFill>
-                  <a:srgbClr val="6B7480"/>
-                </a:solidFill>
-                <a:latin typeface="Garamond"/>
-              </a:rPr>
-              <a:t>1998–2002</a:t>
+            <a:off x="822960" y="1417320"/>
+            <a:ext cx="10789920" cy="1828800"/>
+          </a:xfrm>
+          <a:prstGeom prst="rect">
+            <a:avLst/>
+          </a:prstGeom>
+          <a:noFill/>
+        </p:spPr>
+        <p:txBody>
+          <a:bodyPr wrap="square" lIns="0" rIns="0" tIns="0" bIns="0">
+            <a:spAutoFit/>
+          </a:bodyPr>
+          <a:lstStyle/>
+          <a:p>
+            <a:pPr algn="l">
+              <a:lnSpc>
+                <a:spcPts val="2560"/>
+              </a:lnSpc>
+              <a:spcAft>
+                <a:spcPts val="1000"/>
+              </a:spcAft>
+            </a:pPr>
+            <a:r>
+              <a:rPr sz="2000" b="1" i="0">
+                <a:solidFill>
+                  <a:srgbClr val="2D6CB5"/>
+                </a:solidFill>
+                <a:latin typeface="Garamond"/>
+              </a:rPr>
+              <a:t>▪  </a:t>
+            </a:r>
+            <a:r>
+              <a:rPr sz="2000" b="0" i="0">
+                <a:solidFill>
+                  <a:srgbClr val="212529"/>
+                </a:solidFill>
+                <a:latin typeface="Garamond"/>
+              </a:rPr>
+              <a:t>The census assigns every worker a detailed occupation code for the job held longest last year. We count as a teacher anyone classified in one of the five school-teaching categories:</a:t>
             </a:r>
           </a:p>
         </p:txBody>
@@ -28886,36 +28895,157 @@
         </p:nvSpPr>
         <p:spPr>
           <a:xfrm>
-            <a:off x="7223760" y="1417320"/>
-            <a:ext cx="1737360" cy="365760"/>
-          </a:xfrm>
-          <a:prstGeom prst="rect">
-            <a:avLst/>
-          </a:prstGeom>
-          <a:noFill/>
-        </p:spPr>
-        <p:txBody>
-          <a:bodyPr wrap="square" lIns="0" rIns="0" tIns="0" bIns="0">
-            <a:spAutoFit/>
-          </a:bodyPr>
-          <a:lstStyle/>
-          <a:p>
-            <a:pPr algn="ctr">
-              <a:lnSpc>
-                <a:spcPts val="2048"/>
-              </a:lnSpc>
-              <a:spcAft>
-                <a:spcPts val="0"/>
-              </a:spcAft>
-            </a:pPr>
-            <a:r>
-              <a:rPr sz="1600" b="0" i="0">
-                <a:solidFill>
-                  <a:srgbClr val="6B7480"/>
-                </a:solidFill>
-                <a:latin typeface="Garamond"/>
-              </a:rPr>
-              <a:t>2003–2019</a:t>
+            <a:off x="1417320" y="2542032"/>
+            <a:ext cx="10058400" cy="2011680"/>
+          </a:xfrm>
+          <a:prstGeom prst="rect">
+            <a:avLst/>
+          </a:prstGeom>
+          <a:noFill/>
+        </p:spPr>
+        <p:txBody>
+          <a:bodyPr wrap="square" lIns="0" rIns="0" tIns="0" bIns="0">
+            <a:spAutoFit/>
+          </a:bodyPr>
+          <a:lstStyle/>
+          <a:p>
+            <a:pPr algn="l">
+              <a:lnSpc>
+                <a:spcPts val="2432"/>
+              </a:lnSpc>
+              <a:spcAft>
+                <a:spcPts val="600"/>
+              </a:spcAft>
+            </a:pPr>
+            <a:r>
+              <a:rPr sz="1900" b="1" i="0">
+                <a:solidFill>
+                  <a:srgbClr val="102D5E"/>
+                </a:solidFill>
+                <a:latin typeface="Garamond"/>
+              </a:rPr>
+              <a:t>(a)  </a:t>
+            </a:r>
+            <a:r>
+              <a:rPr sz="1900" b="0" i="0">
+                <a:solidFill>
+                  <a:srgbClr val="212529"/>
+                </a:solidFill>
+                <a:latin typeface="Garamond"/>
+              </a:rPr>
+              <a:t>Preschool and kindergarten teachers</a:t>
+            </a:r>
+          </a:p>
+          <a:p>
+            <a:pPr algn="l">
+              <a:lnSpc>
+                <a:spcPts val="2432"/>
+              </a:lnSpc>
+              <a:spcAft>
+                <a:spcPts val="600"/>
+              </a:spcAft>
+            </a:pPr>
+            <a:r>
+              <a:rPr sz="1900" b="1" i="0">
+                <a:solidFill>
+                  <a:srgbClr val="102D5E"/>
+                </a:solidFill>
+                <a:latin typeface="Garamond"/>
+              </a:rPr>
+              <a:t>(b)  </a:t>
+            </a:r>
+            <a:r>
+              <a:rPr sz="1900" b="0" i="0">
+                <a:solidFill>
+                  <a:srgbClr val="212529"/>
+                </a:solidFill>
+                <a:latin typeface="Garamond"/>
+              </a:rPr>
+              <a:t>Elementary and middle school teachers</a:t>
+            </a:r>
+          </a:p>
+          <a:p>
+            <a:pPr algn="l">
+              <a:lnSpc>
+                <a:spcPts val="2432"/>
+              </a:lnSpc>
+              <a:spcAft>
+                <a:spcPts val="600"/>
+              </a:spcAft>
+            </a:pPr>
+            <a:r>
+              <a:rPr sz="1900" b="1" i="0">
+                <a:solidFill>
+                  <a:srgbClr val="102D5E"/>
+                </a:solidFill>
+                <a:latin typeface="Garamond"/>
+              </a:rPr>
+              <a:t>(c)  </a:t>
+            </a:r>
+            <a:r>
+              <a:rPr sz="1900" b="0" i="0">
+                <a:solidFill>
+                  <a:srgbClr val="212529"/>
+                </a:solidFill>
+                <a:latin typeface="Garamond"/>
+              </a:rPr>
+              <a:t>Secondary school teachers</a:t>
+            </a:r>
+          </a:p>
+          <a:p>
+            <a:pPr algn="l">
+              <a:lnSpc>
+                <a:spcPts val="2432"/>
+              </a:lnSpc>
+              <a:spcAft>
+                <a:spcPts val="600"/>
+              </a:spcAft>
+            </a:pPr>
+            <a:r>
+              <a:rPr sz="1900" b="1" i="0">
+                <a:solidFill>
+                  <a:srgbClr val="102D5E"/>
+                </a:solidFill>
+                <a:latin typeface="Garamond"/>
+              </a:rPr>
+              <a:t>(d)  </a:t>
+            </a:r>
+            <a:r>
+              <a:rPr sz="1900" b="0" i="0">
+                <a:solidFill>
+                  <a:srgbClr val="212529"/>
+                </a:solidFill>
+                <a:latin typeface="Garamond"/>
+              </a:rPr>
+              <a:t>Special education teachers</a:t>
+            </a:r>
+          </a:p>
+          <a:p>
+            <a:pPr algn="l">
+              <a:lnSpc>
+                <a:spcPts val="2432"/>
+              </a:lnSpc>
+              <a:spcAft>
+                <a:spcPts val="600"/>
+              </a:spcAft>
+            </a:pPr>
+            <a:r>
+              <a:rPr sz="1900" b="1" i="0">
+                <a:solidFill>
+                  <a:srgbClr val="102D5E"/>
+                </a:solidFill>
+                <a:latin typeface="Garamond"/>
+              </a:rPr>
+              <a:t>(e)  </a:t>
+            </a:r>
+            <a:r>
+              <a:rPr sz="1900" b="0" i="0">
+                <a:solidFill>
+                  <a:srgbClr val="212529"/>
+                </a:solidFill>
+                <a:latin typeface="Garamond"/>
+              </a:rPr>
+              <a:t>Other teachers and instructors</a:t>
             </a:r>
           </a:p>
         </p:txBody>
@@ -28928,50 +29058,8 @@
         </p:nvSpPr>
         <p:spPr>
           <a:xfrm>
-            <a:off x="9784080" y="1417320"/>
-            <a:ext cx="1737360" cy="365760"/>
-          </a:xfrm>
-          <a:prstGeom prst="rect">
-            <a:avLst/>
-          </a:prstGeom>
-          <a:noFill/>
-        </p:spPr>
-        <p:txBody>
-          <a:bodyPr wrap="square" lIns="0" rIns="0" tIns="0" bIns="0">
-            <a:spAutoFit/>
-          </a:bodyPr>
-          <a:lstStyle/>
-          <a:p>
-            <a:pPr algn="ctr">
-              <a:lnSpc>
-                <a:spcPts val="2048"/>
-              </a:lnSpc>
-              <a:spcAft>
-                <a:spcPts val="0"/>
-              </a:spcAft>
-            </a:pPr>
-            <a:r>
-              <a:rPr sz="1600" b="0" i="0">
-                <a:solidFill>
-                  <a:srgbClr val="6B7480"/>
-                </a:solidFill>
-                <a:latin typeface="Garamond"/>
-              </a:rPr>
-              <a:t>2020–2025</a:t>
-            </a:r>
-          </a:p>
-        </p:txBody>
-      </p:sp>
-      <p:sp>
-        <p:nvSpPr>
-          <p:cNvPr id="7" name="TextBox 6"/>
-          <p:cNvSpPr txBox="1"/>
-          <p:nvPr/>
-        </p:nvSpPr>
-        <p:spPr>
-          <a:xfrm>
-            <a:off x="822960" y="1965960"/>
-            <a:ext cx="3657600" cy="411480"/>
+            <a:off x="822960" y="4892040"/>
+            <a:ext cx="10789920" cy="1188720"/>
           </a:xfrm>
           <a:prstGeom prst="rect">
             <a:avLst/>
@@ -28986,1287 +29074,36 @@
           <a:p>
             <a:pPr algn="l">
               <a:lnSpc>
-                <a:spcPts val="2304"/>
-              </a:lnSpc>
-              <a:spcAft>
-                <a:spcPts val="0"/>
-              </a:spcAft>
-            </a:pPr>
-            <a:r>
-              <a:rPr sz="1800" b="0" i="0">
+                <a:spcPts val="2560"/>
+              </a:lnSpc>
+              <a:spcAft>
+                <a:spcPts val="0"/>
+              </a:spcAft>
+            </a:pPr>
+            <a:r>
+              <a:rPr sz="2000" b="1" i="0">
+                <a:solidFill>
+                  <a:srgbClr val="2D6CB5"/>
+                </a:solidFill>
+                <a:latin typeface="Garamond"/>
+              </a:rPr>
+              <a:t>▪  </a:t>
+            </a:r>
+            <a:r>
+              <a:rPr sz="2000" b="0" i="0">
                 <a:solidFill>
                   <a:srgbClr val="212529"/>
                 </a:solidFill>
                 <a:latin typeface="Garamond"/>
               </a:rPr>
-              <a:t>Pre-K and kindergarten</a:t>
-            </a:r>
-          </a:p>
-        </p:txBody>
-      </p:sp>
-      <p:sp>
-        <p:nvSpPr>
-          <p:cNvPr id="8" name="TextBox 7"/>
-          <p:cNvSpPr txBox="1"/>
-          <p:nvPr/>
-        </p:nvSpPr>
-        <p:spPr>
-          <a:xfrm>
-            <a:off x="4663440" y="1965960"/>
-            <a:ext cx="1737360" cy="411480"/>
-          </a:xfrm>
-          <a:prstGeom prst="rect">
-            <a:avLst/>
-          </a:prstGeom>
-          <a:noFill/>
-        </p:spPr>
-        <p:txBody>
-          <a:bodyPr wrap="square" lIns="0" rIns="0" tIns="0" bIns="0">
-            <a:spAutoFit/>
-          </a:bodyPr>
-          <a:lstStyle/>
-          <a:p>
-            <a:pPr algn="ctr">
-              <a:lnSpc>
-                <a:spcPts val="2304"/>
-              </a:lnSpc>
-              <a:spcAft>
-                <a:spcPts val="0"/>
-              </a:spcAft>
-            </a:pPr>
-            <a:r>
-              <a:rPr sz="1800" b="1" i="0">
-                <a:solidFill>
-                  <a:srgbClr val="102D5E"/>
-                </a:solidFill>
-                <a:latin typeface="Garamond"/>
-              </a:rPr>
-              <a:t>155</a:t>
-            </a:r>
-          </a:p>
-        </p:txBody>
-      </p:sp>
-      <p:sp>
-        <p:nvSpPr>
-          <p:cNvPr id="9" name="TextBox 8"/>
-          <p:cNvSpPr txBox="1"/>
-          <p:nvPr/>
-        </p:nvSpPr>
-        <p:spPr>
-          <a:xfrm>
-            <a:off x="6309360" y="1965960"/>
-            <a:ext cx="1005840" cy="411480"/>
-          </a:xfrm>
-          <a:prstGeom prst="rect">
-            <a:avLst/>
-          </a:prstGeom>
-          <a:noFill/>
-        </p:spPr>
-        <p:txBody>
-          <a:bodyPr wrap="square" lIns="0" rIns="0" tIns="0" bIns="0">
-            <a:spAutoFit/>
-          </a:bodyPr>
-          <a:lstStyle/>
-          <a:p>
-            <a:pPr algn="ctr">
-              <a:lnSpc>
-                <a:spcPts val="2304"/>
-              </a:lnSpc>
-              <a:spcAft>
-                <a:spcPts val="0"/>
-              </a:spcAft>
-            </a:pPr>
-            <a:r>
-              <a:rPr sz="1800" b="0" i="0">
-                <a:solidFill>
-                  <a:srgbClr val="6B7480"/>
-                </a:solidFill>
-                <a:latin typeface="Garamond"/>
-              </a:rPr>
-              <a:t>→</a:t>
-            </a:r>
-          </a:p>
-        </p:txBody>
-      </p:sp>
-      <p:sp>
-        <p:nvSpPr>
-          <p:cNvPr id="10" name="TextBox 9"/>
-          <p:cNvSpPr txBox="1"/>
-          <p:nvPr/>
-        </p:nvSpPr>
-        <p:spPr>
-          <a:xfrm>
-            <a:off x="7223760" y="1965960"/>
-            <a:ext cx="1737360" cy="411480"/>
-          </a:xfrm>
-          <a:prstGeom prst="rect">
-            <a:avLst/>
-          </a:prstGeom>
-          <a:noFill/>
-        </p:spPr>
-        <p:txBody>
-          <a:bodyPr wrap="square" lIns="0" rIns="0" tIns="0" bIns="0">
-            <a:spAutoFit/>
-          </a:bodyPr>
-          <a:lstStyle/>
-          <a:p>
-            <a:pPr algn="ctr">
-              <a:lnSpc>
-                <a:spcPts val="2304"/>
-              </a:lnSpc>
-              <a:spcAft>
-                <a:spcPts val="0"/>
-              </a:spcAft>
-            </a:pPr>
-            <a:r>
-              <a:rPr sz="1800" b="1" i="0">
-                <a:solidFill>
-                  <a:srgbClr val="102D5E"/>
-                </a:solidFill>
-                <a:latin typeface="Garamond"/>
-              </a:rPr>
-              <a:t>2300</a:t>
-            </a:r>
-          </a:p>
-        </p:txBody>
-      </p:sp>
-      <p:sp>
-        <p:nvSpPr>
-          <p:cNvPr id="11" name="TextBox 10"/>
-          <p:cNvSpPr txBox="1"/>
-          <p:nvPr/>
-        </p:nvSpPr>
-        <p:spPr>
-          <a:xfrm>
-            <a:off x="8869680" y="1965960"/>
-            <a:ext cx="1005840" cy="411480"/>
-          </a:xfrm>
-          <a:prstGeom prst="rect">
-            <a:avLst/>
-          </a:prstGeom>
-          <a:noFill/>
-        </p:spPr>
-        <p:txBody>
-          <a:bodyPr wrap="square" lIns="0" rIns="0" tIns="0" bIns="0">
-            <a:spAutoFit/>
-          </a:bodyPr>
-          <a:lstStyle/>
-          <a:p>
-            <a:pPr algn="ctr">
-              <a:lnSpc>
-                <a:spcPts val="2304"/>
-              </a:lnSpc>
-              <a:spcAft>
-                <a:spcPts val="0"/>
-              </a:spcAft>
-            </a:pPr>
-            <a:r>
-              <a:rPr sz="1800" b="0" i="0">
-                <a:solidFill>
-                  <a:srgbClr val="6B7480"/>
-                </a:solidFill>
-                <a:latin typeface="Garamond"/>
-              </a:rPr>
-              <a:t>=</a:t>
-            </a:r>
-          </a:p>
-        </p:txBody>
-      </p:sp>
-      <p:sp>
-        <p:nvSpPr>
-          <p:cNvPr id="12" name="TextBox 11"/>
-          <p:cNvSpPr txBox="1"/>
-          <p:nvPr/>
-        </p:nvSpPr>
-        <p:spPr>
-          <a:xfrm>
-            <a:off x="9784080" y="1965960"/>
-            <a:ext cx="1737360" cy="411480"/>
-          </a:xfrm>
-          <a:prstGeom prst="rect">
-            <a:avLst/>
-          </a:prstGeom>
-          <a:noFill/>
-        </p:spPr>
-        <p:txBody>
-          <a:bodyPr wrap="square" lIns="0" rIns="0" tIns="0" bIns="0">
-            <a:spAutoFit/>
-          </a:bodyPr>
-          <a:lstStyle/>
-          <a:p>
-            <a:pPr algn="ctr">
-              <a:lnSpc>
-                <a:spcPts val="2304"/>
-              </a:lnSpc>
-              <a:spcAft>
-                <a:spcPts val="0"/>
-              </a:spcAft>
-            </a:pPr>
-            <a:r>
-              <a:rPr sz="1800" b="1" i="0">
-                <a:solidFill>
-                  <a:srgbClr val="102D5E"/>
-                </a:solidFill>
-                <a:latin typeface="Garamond"/>
-              </a:rPr>
-              <a:t>2300</a:t>
-            </a:r>
-          </a:p>
-        </p:txBody>
-      </p:sp>
-      <p:sp>
-        <p:nvSpPr>
-          <p:cNvPr id="13" name="TextBox 12"/>
-          <p:cNvSpPr txBox="1"/>
-          <p:nvPr/>
-        </p:nvSpPr>
-        <p:spPr>
-          <a:xfrm>
-            <a:off x="822960" y="2532888"/>
-            <a:ext cx="3657600" cy="411480"/>
-          </a:xfrm>
-          <a:prstGeom prst="rect">
-            <a:avLst/>
-          </a:prstGeom>
-          <a:noFill/>
-        </p:spPr>
-        <p:txBody>
-          <a:bodyPr wrap="square" lIns="0" rIns="0" tIns="0" bIns="0">
-            <a:spAutoFit/>
-          </a:bodyPr>
-          <a:lstStyle/>
-          <a:p>
-            <a:pPr algn="l">
-              <a:lnSpc>
-                <a:spcPts val="2304"/>
-              </a:lnSpc>
-              <a:spcAft>
-                <a:spcPts val="0"/>
-              </a:spcAft>
-            </a:pPr>
-            <a:r>
-              <a:rPr sz="1800" b="0" i="0">
-                <a:solidFill>
-                  <a:srgbClr val="212529"/>
-                </a:solidFill>
-                <a:latin typeface="Garamond"/>
-              </a:rPr>
-              <a:t>Elementary (and middle)</a:t>
-            </a:r>
-          </a:p>
-        </p:txBody>
-      </p:sp>
-      <p:sp>
-        <p:nvSpPr>
-          <p:cNvPr id="14" name="TextBox 13"/>
-          <p:cNvSpPr txBox="1"/>
-          <p:nvPr/>
-        </p:nvSpPr>
-        <p:spPr>
-          <a:xfrm>
-            <a:off x="4663440" y="2532888"/>
-            <a:ext cx="1737360" cy="411480"/>
-          </a:xfrm>
-          <a:prstGeom prst="rect">
-            <a:avLst/>
-          </a:prstGeom>
-          <a:noFill/>
-        </p:spPr>
-        <p:txBody>
-          <a:bodyPr wrap="square" lIns="0" rIns="0" tIns="0" bIns="0">
-            <a:spAutoFit/>
-          </a:bodyPr>
-          <a:lstStyle/>
-          <a:p>
-            <a:pPr algn="ctr">
-              <a:lnSpc>
-                <a:spcPts val="2304"/>
-              </a:lnSpc>
-              <a:spcAft>
-                <a:spcPts val="0"/>
-              </a:spcAft>
-            </a:pPr>
-            <a:r>
-              <a:rPr sz="1800" b="1" i="0">
-                <a:solidFill>
-                  <a:srgbClr val="102D5E"/>
-                </a:solidFill>
-                <a:latin typeface="Garamond"/>
-              </a:rPr>
-              <a:t>156</a:t>
-            </a:r>
-          </a:p>
-        </p:txBody>
-      </p:sp>
-      <p:sp>
-        <p:nvSpPr>
-          <p:cNvPr id="15" name="TextBox 14"/>
-          <p:cNvSpPr txBox="1"/>
-          <p:nvPr/>
-        </p:nvSpPr>
-        <p:spPr>
-          <a:xfrm>
-            <a:off x="6309360" y="2532888"/>
-            <a:ext cx="1005840" cy="411480"/>
-          </a:xfrm>
-          <a:prstGeom prst="rect">
-            <a:avLst/>
-          </a:prstGeom>
-          <a:noFill/>
-        </p:spPr>
-        <p:txBody>
-          <a:bodyPr wrap="square" lIns="0" rIns="0" tIns="0" bIns="0">
-            <a:spAutoFit/>
-          </a:bodyPr>
-          <a:lstStyle/>
-          <a:p>
-            <a:pPr algn="ctr">
-              <a:lnSpc>
-                <a:spcPts val="2304"/>
-              </a:lnSpc>
-              <a:spcAft>
-                <a:spcPts val="0"/>
-              </a:spcAft>
-            </a:pPr>
-            <a:r>
-              <a:rPr sz="1800" b="0" i="0">
-                <a:solidFill>
-                  <a:srgbClr val="6B7480"/>
-                </a:solidFill>
-                <a:latin typeface="Garamond"/>
-              </a:rPr>
-              <a:t>→</a:t>
-            </a:r>
-          </a:p>
-        </p:txBody>
-      </p:sp>
-      <p:sp>
-        <p:nvSpPr>
-          <p:cNvPr id="16" name="TextBox 15"/>
-          <p:cNvSpPr txBox="1"/>
-          <p:nvPr/>
-        </p:nvSpPr>
-        <p:spPr>
-          <a:xfrm>
-            <a:off x="7223760" y="2532888"/>
-            <a:ext cx="1737360" cy="411480"/>
-          </a:xfrm>
-          <a:prstGeom prst="rect">
-            <a:avLst/>
-          </a:prstGeom>
-          <a:noFill/>
-        </p:spPr>
-        <p:txBody>
-          <a:bodyPr wrap="square" lIns="0" rIns="0" tIns="0" bIns="0">
-            <a:spAutoFit/>
-          </a:bodyPr>
-          <a:lstStyle/>
-          <a:p>
-            <a:pPr algn="ctr">
-              <a:lnSpc>
-                <a:spcPts val="2304"/>
-              </a:lnSpc>
-              <a:spcAft>
-                <a:spcPts val="0"/>
-              </a:spcAft>
-            </a:pPr>
-            <a:r>
-              <a:rPr sz="1800" b="1" i="0">
-                <a:solidFill>
-                  <a:srgbClr val="102D5E"/>
-                </a:solidFill>
-                <a:latin typeface="Garamond"/>
-              </a:rPr>
-              <a:t>2310</a:t>
-            </a:r>
-          </a:p>
-        </p:txBody>
-      </p:sp>
-      <p:sp>
-        <p:nvSpPr>
-          <p:cNvPr id="17" name="TextBox 16"/>
-          <p:cNvSpPr txBox="1"/>
-          <p:nvPr/>
-        </p:nvSpPr>
-        <p:spPr>
-          <a:xfrm>
-            <a:off x="8869680" y="2532888"/>
-            <a:ext cx="1005840" cy="411480"/>
-          </a:xfrm>
-          <a:prstGeom prst="rect">
-            <a:avLst/>
-          </a:prstGeom>
-          <a:noFill/>
-        </p:spPr>
-        <p:txBody>
-          <a:bodyPr wrap="square" lIns="0" rIns="0" tIns="0" bIns="0">
-            <a:spAutoFit/>
-          </a:bodyPr>
-          <a:lstStyle/>
-          <a:p>
-            <a:pPr algn="ctr">
-              <a:lnSpc>
-                <a:spcPts val="2304"/>
-              </a:lnSpc>
-              <a:spcAft>
-                <a:spcPts val="0"/>
-              </a:spcAft>
-            </a:pPr>
-            <a:r>
-              <a:rPr sz="1800" b="0" i="0">
-                <a:solidFill>
-                  <a:srgbClr val="6B7480"/>
-                </a:solidFill>
-                <a:latin typeface="Garamond"/>
-              </a:rPr>
-              <a:t>=</a:t>
-            </a:r>
-          </a:p>
-        </p:txBody>
-      </p:sp>
-      <p:sp>
-        <p:nvSpPr>
-          <p:cNvPr id="18" name="TextBox 17"/>
-          <p:cNvSpPr txBox="1"/>
-          <p:nvPr/>
-        </p:nvSpPr>
-        <p:spPr>
-          <a:xfrm>
-            <a:off x="9784080" y="2532888"/>
-            <a:ext cx="1737360" cy="411480"/>
-          </a:xfrm>
-          <a:prstGeom prst="rect">
-            <a:avLst/>
-          </a:prstGeom>
-          <a:noFill/>
-        </p:spPr>
-        <p:txBody>
-          <a:bodyPr wrap="square" lIns="0" rIns="0" tIns="0" bIns="0">
-            <a:spAutoFit/>
-          </a:bodyPr>
-          <a:lstStyle/>
-          <a:p>
-            <a:pPr algn="ctr">
-              <a:lnSpc>
-                <a:spcPts val="2304"/>
-              </a:lnSpc>
-              <a:spcAft>
-                <a:spcPts val="0"/>
-              </a:spcAft>
-            </a:pPr>
-            <a:r>
-              <a:rPr sz="1800" b="1" i="0">
-                <a:solidFill>
-                  <a:srgbClr val="102D5E"/>
-                </a:solidFill>
-                <a:latin typeface="Garamond"/>
-              </a:rPr>
-              <a:t>2310</a:t>
-            </a:r>
-          </a:p>
-        </p:txBody>
-      </p:sp>
-      <p:sp>
-        <p:nvSpPr>
-          <p:cNvPr id="19" name="TextBox 18"/>
-          <p:cNvSpPr txBox="1"/>
-          <p:nvPr/>
-        </p:nvSpPr>
-        <p:spPr>
-          <a:xfrm>
-            <a:off x="822960" y="3099816"/>
-            <a:ext cx="3657600" cy="411480"/>
-          </a:xfrm>
-          <a:prstGeom prst="rect">
-            <a:avLst/>
-          </a:prstGeom>
-          <a:noFill/>
-        </p:spPr>
-        <p:txBody>
-          <a:bodyPr wrap="square" lIns="0" rIns="0" tIns="0" bIns="0">
-            <a:spAutoFit/>
-          </a:bodyPr>
-          <a:lstStyle/>
-          <a:p>
-            <a:pPr algn="l">
-              <a:lnSpc>
-                <a:spcPts val="2304"/>
-              </a:lnSpc>
-              <a:spcAft>
-                <a:spcPts val="0"/>
-              </a:spcAft>
-            </a:pPr>
-            <a:r>
-              <a:rPr sz="1800" b="0" i="0">
-                <a:solidFill>
-                  <a:srgbClr val="212529"/>
-                </a:solidFill>
-                <a:latin typeface="Garamond"/>
-              </a:rPr>
-              <a:t>Secondary</a:t>
-            </a:r>
-          </a:p>
-        </p:txBody>
-      </p:sp>
-      <p:sp>
-        <p:nvSpPr>
-          <p:cNvPr id="20" name="TextBox 19"/>
-          <p:cNvSpPr txBox="1"/>
-          <p:nvPr/>
-        </p:nvSpPr>
-        <p:spPr>
-          <a:xfrm>
-            <a:off x="4663440" y="3099816"/>
-            <a:ext cx="1737360" cy="411480"/>
-          </a:xfrm>
-          <a:prstGeom prst="rect">
-            <a:avLst/>
-          </a:prstGeom>
-          <a:noFill/>
-        </p:spPr>
-        <p:txBody>
-          <a:bodyPr wrap="square" lIns="0" rIns="0" tIns="0" bIns="0">
-            <a:spAutoFit/>
-          </a:bodyPr>
-          <a:lstStyle/>
-          <a:p>
-            <a:pPr algn="ctr">
-              <a:lnSpc>
-                <a:spcPts val="2304"/>
-              </a:lnSpc>
-              <a:spcAft>
-                <a:spcPts val="0"/>
-              </a:spcAft>
-            </a:pPr>
-            <a:r>
-              <a:rPr sz="1800" b="1" i="0">
-                <a:solidFill>
-                  <a:srgbClr val="102D5E"/>
-                </a:solidFill>
-                <a:latin typeface="Garamond"/>
-              </a:rPr>
-              <a:t>157</a:t>
-            </a:r>
-          </a:p>
-        </p:txBody>
-      </p:sp>
-      <p:sp>
-        <p:nvSpPr>
-          <p:cNvPr id="21" name="TextBox 20"/>
-          <p:cNvSpPr txBox="1"/>
-          <p:nvPr/>
-        </p:nvSpPr>
-        <p:spPr>
-          <a:xfrm>
-            <a:off x="6309360" y="3099816"/>
-            <a:ext cx="1005840" cy="411480"/>
-          </a:xfrm>
-          <a:prstGeom prst="rect">
-            <a:avLst/>
-          </a:prstGeom>
-          <a:noFill/>
-        </p:spPr>
-        <p:txBody>
-          <a:bodyPr wrap="square" lIns="0" rIns="0" tIns="0" bIns="0">
-            <a:spAutoFit/>
-          </a:bodyPr>
-          <a:lstStyle/>
-          <a:p>
-            <a:pPr algn="ctr">
-              <a:lnSpc>
-                <a:spcPts val="2304"/>
-              </a:lnSpc>
-              <a:spcAft>
-                <a:spcPts val="0"/>
-              </a:spcAft>
-            </a:pPr>
-            <a:r>
-              <a:rPr sz="1800" b="0" i="0">
-                <a:solidFill>
-                  <a:srgbClr val="6B7480"/>
-                </a:solidFill>
-                <a:latin typeface="Garamond"/>
-              </a:rPr>
-              <a:t>→</a:t>
-            </a:r>
-          </a:p>
-        </p:txBody>
-      </p:sp>
-      <p:sp>
-        <p:nvSpPr>
-          <p:cNvPr id="22" name="TextBox 21"/>
-          <p:cNvSpPr txBox="1"/>
-          <p:nvPr/>
-        </p:nvSpPr>
-        <p:spPr>
-          <a:xfrm>
-            <a:off x="7223760" y="3099816"/>
-            <a:ext cx="1737360" cy="411480"/>
-          </a:xfrm>
-          <a:prstGeom prst="rect">
-            <a:avLst/>
-          </a:prstGeom>
-          <a:noFill/>
-        </p:spPr>
-        <p:txBody>
-          <a:bodyPr wrap="square" lIns="0" rIns="0" tIns="0" bIns="0">
-            <a:spAutoFit/>
-          </a:bodyPr>
-          <a:lstStyle/>
-          <a:p>
-            <a:pPr algn="ctr">
-              <a:lnSpc>
-                <a:spcPts val="2304"/>
-              </a:lnSpc>
-              <a:spcAft>
-                <a:spcPts val="0"/>
-              </a:spcAft>
-            </a:pPr>
-            <a:r>
-              <a:rPr sz="1800" b="1" i="0">
-                <a:solidFill>
-                  <a:srgbClr val="102D5E"/>
-                </a:solidFill>
-                <a:latin typeface="Garamond"/>
-              </a:rPr>
-              <a:t>2320</a:t>
-            </a:r>
-          </a:p>
-        </p:txBody>
-      </p:sp>
-      <p:sp>
-        <p:nvSpPr>
-          <p:cNvPr id="23" name="TextBox 22"/>
-          <p:cNvSpPr txBox="1"/>
-          <p:nvPr/>
-        </p:nvSpPr>
-        <p:spPr>
-          <a:xfrm>
-            <a:off x="8869680" y="3099816"/>
-            <a:ext cx="1005840" cy="411480"/>
-          </a:xfrm>
-          <a:prstGeom prst="rect">
-            <a:avLst/>
-          </a:prstGeom>
-          <a:noFill/>
-        </p:spPr>
-        <p:txBody>
-          <a:bodyPr wrap="square" lIns="0" rIns="0" tIns="0" bIns="0">
-            <a:spAutoFit/>
-          </a:bodyPr>
-          <a:lstStyle/>
-          <a:p>
-            <a:pPr algn="ctr">
-              <a:lnSpc>
-                <a:spcPts val="2304"/>
-              </a:lnSpc>
-              <a:spcAft>
-                <a:spcPts val="0"/>
-              </a:spcAft>
-            </a:pPr>
-            <a:r>
-              <a:rPr sz="1800" b="0" i="0">
-                <a:solidFill>
-                  <a:srgbClr val="6B7480"/>
-                </a:solidFill>
-                <a:latin typeface="Garamond"/>
-              </a:rPr>
-              <a:t>=</a:t>
-            </a:r>
-          </a:p>
-        </p:txBody>
-      </p:sp>
-      <p:sp>
-        <p:nvSpPr>
-          <p:cNvPr id="24" name="TextBox 23"/>
-          <p:cNvSpPr txBox="1"/>
-          <p:nvPr/>
-        </p:nvSpPr>
-        <p:spPr>
-          <a:xfrm>
-            <a:off x="9784080" y="3099816"/>
-            <a:ext cx="1737360" cy="411480"/>
-          </a:xfrm>
-          <a:prstGeom prst="rect">
-            <a:avLst/>
-          </a:prstGeom>
-          <a:noFill/>
-        </p:spPr>
-        <p:txBody>
-          <a:bodyPr wrap="square" lIns="0" rIns="0" tIns="0" bIns="0">
-            <a:spAutoFit/>
-          </a:bodyPr>
-          <a:lstStyle/>
-          <a:p>
-            <a:pPr algn="ctr">
-              <a:lnSpc>
-                <a:spcPts val="2304"/>
-              </a:lnSpc>
-              <a:spcAft>
-                <a:spcPts val="0"/>
-              </a:spcAft>
-            </a:pPr>
-            <a:r>
-              <a:rPr sz="1800" b="1" i="0">
-                <a:solidFill>
-                  <a:srgbClr val="102D5E"/>
-                </a:solidFill>
-                <a:latin typeface="Garamond"/>
-              </a:rPr>
-              <a:t>2320</a:t>
-            </a:r>
-          </a:p>
-        </p:txBody>
-      </p:sp>
-      <p:sp>
-        <p:nvSpPr>
-          <p:cNvPr id="25" name="TextBox 24"/>
-          <p:cNvSpPr txBox="1"/>
-          <p:nvPr/>
-        </p:nvSpPr>
-        <p:spPr>
-          <a:xfrm>
-            <a:off x="822960" y="3666744"/>
-            <a:ext cx="3657600" cy="411480"/>
-          </a:xfrm>
-          <a:prstGeom prst="rect">
-            <a:avLst/>
-          </a:prstGeom>
-          <a:noFill/>
-        </p:spPr>
-        <p:txBody>
-          <a:bodyPr wrap="square" lIns="0" rIns="0" tIns="0" bIns="0">
-            <a:spAutoFit/>
-          </a:bodyPr>
-          <a:lstStyle/>
-          <a:p>
-            <a:pPr algn="l">
-              <a:lnSpc>
-                <a:spcPts val="2304"/>
-              </a:lnSpc>
-              <a:spcAft>
-                <a:spcPts val="0"/>
-              </a:spcAft>
-            </a:pPr>
-            <a:r>
-              <a:rPr sz="1800" b="0" i="0">
-                <a:solidFill>
-                  <a:srgbClr val="212529"/>
-                </a:solidFill>
-                <a:latin typeface="Garamond"/>
-              </a:rPr>
-              <a:t>Special education</a:t>
-            </a:r>
-          </a:p>
-        </p:txBody>
-      </p:sp>
-      <p:sp>
-        <p:nvSpPr>
-          <p:cNvPr id="26" name="TextBox 25"/>
-          <p:cNvSpPr txBox="1"/>
-          <p:nvPr/>
-        </p:nvSpPr>
-        <p:spPr>
-          <a:xfrm>
-            <a:off x="4663440" y="3666744"/>
-            <a:ext cx="1737360" cy="411480"/>
-          </a:xfrm>
-          <a:prstGeom prst="rect">
-            <a:avLst/>
-          </a:prstGeom>
-          <a:noFill/>
-        </p:spPr>
-        <p:txBody>
-          <a:bodyPr wrap="square" lIns="0" rIns="0" tIns="0" bIns="0">
-            <a:spAutoFit/>
-          </a:bodyPr>
-          <a:lstStyle/>
-          <a:p>
-            <a:pPr algn="ctr">
-              <a:lnSpc>
-                <a:spcPts val="2304"/>
-              </a:lnSpc>
-              <a:spcAft>
-                <a:spcPts val="0"/>
-              </a:spcAft>
-            </a:pPr>
-            <a:r>
-              <a:rPr sz="1800" b="1" i="0">
-                <a:solidFill>
-                  <a:srgbClr val="102D5E"/>
-                </a:solidFill>
-                <a:latin typeface="Garamond"/>
-              </a:rPr>
-              <a:t>158</a:t>
-            </a:r>
-          </a:p>
-        </p:txBody>
-      </p:sp>
-      <p:sp>
-        <p:nvSpPr>
-          <p:cNvPr id="27" name="TextBox 26"/>
-          <p:cNvSpPr txBox="1"/>
-          <p:nvPr/>
-        </p:nvSpPr>
-        <p:spPr>
-          <a:xfrm>
-            <a:off x="6309360" y="3666744"/>
-            <a:ext cx="1005840" cy="411480"/>
-          </a:xfrm>
-          <a:prstGeom prst="rect">
-            <a:avLst/>
-          </a:prstGeom>
-          <a:noFill/>
-        </p:spPr>
-        <p:txBody>
-          <a:bodyPr wrap="square" lIns="0" rIns="0" tIns="0" bIns="0">
-            <a:spAutoFit/>
-          </a:bodyPr>
-          <a:lstStyle/>
-          <a:p>
-            <a:pPr algn="ctr">
-              <a:lnSpc>
-                <a:spcPts val="2304"/>
-              </a:lnSpc>
-              <a:spcAft>
-                <a:spcPts val="0"/>
-              </a:spcAft>
-            </a:pPr>
-            <a:r>
-              <a:rPr sz="1800" b="0" i="0">
-                <a:solidFill>
-                  <a:srgbClr val="6B7480"/>
-                </a:solidFill>
-                <a:latin typeface="Garamond"/>
-              </a:rPr>
-              <a:t>→</a:t>
-            </a:r>
-          </a:p>
-        </p:txBody>
-      </p:sp>
-      <p:sp>
-        <p:nvSpPr>
-          <p:cNvPr id="28" name="TextBox 27"/>
-          <p:cNvSpPr txBox="1"/>
-          <p:nvPr/>
-        </p:nvSpPr>
-        <p:spPr>
-          <a:xfrm>
-            <a:off x="7223760" y="3666744"/>
-            <a:ext cx="1737360" cy="411480"/>
-          </a:xfrm>
-          <a:prstGeom prst="rect">
-            <a:avLst/>
-          </a:prstGeom>
-          <a:noFill/>
-        </p:spPr>
-        <p:txBody>
-          <a:bodyPr wrap="square" lIns="0" rIns="0" tIns="0" bIns="0">
-            <a:spAutoFit/>
-          </a:bodyPr>
-          <a:lstStyle/>
-          <a:p>
-            <a:pPr algn="ctr">
-              <a:lnSpc>
-                <a:spcPts val="2304"/>
-              </a:lnSpc>
-              <a:spcAft>
-                <a:spcPts val="0"/>
-              </a:spcAft>
-            </a:pPr>
-            <a:r>
-              <a:rPr sz="1800" b="1" i="0">
-                <a:solidFill>
-                  <a:srgbClr val="102D5E"/>
-                </a:solidFill>
-                <a:latin typeface="Garamond"/>
-              </a:rPr>
-              <a:t>2330</a:t>
-            </a:r>
-          </a:p>
-        </p:txBody>
-      </p:sp>
-      <p:sp>
-        <p:nvSpPr>
-          <p:cNvPr id="29" name="TextBox 28"/>
-          <p:cNvSpPr txBox="1"/>
-          <p:nvPr/>
-        </p:nvSpPr>
-        <p:spPr>
-          <a:xfrm>
-            <a:off x="8869680" y="3666744"/>
-            <a:ext cx="1005840" cy="411480"/>
-          </a:xfrm>
-          <a:prstGeom prst="rect">
-            <a:avLst/>
-          </a:prstGeom>
-          <a:noFill/>
-        </p:spPr>
-        <p:txBody>
-          <a:bodyPr wrap="square" lIns="0" rIns="0" tIns="0" bIns="0">
-            <a:spAutoFit/>
-          </a:bodyPr>
-          <a:lstStyle/>
-          <a:p>
-            <a:pPr algn="ctr">
-              <a:lnSpc>
-                <a:spcPts val="2304"/>
-              </a:lnSpc>
-              <a:spcAft>
-                <a:spcPts val="0"/>
-              </a:spcAft>
-            </a:pPr>
-            <a:r>
-              <a:rPr sz="1800" b="0" i="0">
-                <a:solidFill>
-                  <a:srgbClr val="6B7480"/>
-                </a:solidFill>
-                <a:latin typeface="Garamond"/>
-              </a:rPr>
-              <a:t>=</a:t>
-            </a:r>
-          </a:p>
-        </p:txBody>
-      </p:sp>
-      <p:sp>
-        <p:nvSpPr>
-          <p:cNvPr id="30" name="TextBox 29"/>
-          <p:cNvSpPr txBox="1"/>
-          <p:nvPr/>
-        </p:nvSpPr>
-        <p:spPr>
-          <a:xfrm>
-            <a:off x="9784080" y="3666744"/>
-            <a:ext cx="1737360" cy="411480"/>
-          </a:xfrm>
-          <a:prstGeom prst="rect">
-            <a:avLst/>
-          </a:prstGeom>
-          <a:noFill/>
-        </p:spPr>
-        <p:txBody>
-          <a:bodyPr wrap="square" lIns="0" rIns="0" tIns="0" bIns="0">
-            <a:spAutoFit/>
-          </a:bodyPr>
-          <a:lstStyle/>
-          <a:p>
-            <a:pPr algn="ctr">
-              <a:lnSpc>
-                <a:spcPts val="2304"/>
-              </a:lnSpc>
-              <a:spcAft>
-                <a:spcPts val="0"/>
-              </a:spcAft>
-            </a:pPr>
-            <a:r>
-              <a:rPr sz="1800" b="1" i="0">
-                <a:solidFill>
-                  <a:srgbClr val="102D5E"/>
-                </a:solidFill>
-                <a:latin typeface="Garamond"/>
-              </a:rPr>
-              <a:t>2330</a:t>
-            </a:r>
-          </a:p>
-        </p:txBody>
-      </p:sp>
-      <p:sp>
-        <p:nvSpPr>
-          <p:cNvPr id="31" name="TextBox 30"/>
-          <p:cNvSpPr txBox="1"/>
-          <p:nvPr/>
-        </p:nvSpPr>
-        <p:spPr>
-          <a:xfrm>
-            <a:off x="822960" y="4233672"/>
-            <a:ext cx="3657600" cy="411480"/>
-          </a:xfrm>
-          <a:prstGeom prst="rect">
-            <a:avLst/>
-          </a:prstGeom>
-          <a:noFill/>
-        </p:spPr>
-        <p:txBody>
-          <a:bodyPr wrap="square" lIns="0" rIns="0" tIns="0" bIns="0">
-            <a:spAutoFit/>
-          </a:bodyPr>
-          <a:lstStyle/>
-          <a:p>
-            <a:pPr algn="l">
-              <a:lnSpc>
-                <a:spcPts val="2304"/>
-              </a:lnSpc>
-              <a:spcAft>
-                <a:spcPts val="0"/>
-              </a:spcAft>
-            </a:pPr>
-            <a:r>
-              <a:rPr sz="1800" b="0" i="0">
-                <a:solidFill>
-                  <a:srgbClr val="212529"/>
-                </a:solidFill>
-                <a:latin typeface="Garamond"/>
-              </a:rPr>
-              <a:t>Other teachers and instructors</a:t>
-            </a:r>
-          </a:p>
-        </p:txBody>
-      </p:sp>
-      <p:sp>
-        <p:nvSpPr>
-          <p:cNvPr id="32" name="TextBox 31"/>
-          <p:cNvSpPr txBox="1"/>
-          <p:nvPr/>
-        </p:nvSpPr>
-        <p:spPr>
-          <a:xfrm>
-            <a:off x="4663440" y="4233672"/>
-            <a:ext cx="1737360" cy="411480"/>
-          </a:xfrm>
-          <a:prstGeom prst="rect">
-            <a:avLst/>
-          </a:prstGeom>
-          <a:noFill/>
-        </p:spPr>
-        <p:txBody>
-          <a:bodyPr wrap="square" lIns="0" rIns="0" tIns="0" bIns="0">
-            <a:spAutoFit/>
-          </a:bodyPr>
-          <a:lstStyle/>
-          <a:p>
-            <a:pPr algn="ctr">
-              <a:lnSpc>
-                <a:spcPts val="2304"/>
-              </a:lnSpc>
-              <a:spcAft>
-                <a:spcPts val="0"/>
-              </a:spcAft>
-            </a:pPr>
-            <a:r>
-              <a:rPr sz="1800" b="1" i="0">
-                <a:solidFill>
-                  <a:srgbClr val="102D5E"/>
-                </a:solidFill>
-                <a:latin typeface="Garamond"/>
-              </a:rPr>
-              <a:t>159</a:t>
-            </a:r>
-          </a:p>
-        </p:txBody>
-      </p:sp>
-      <p:sp>
-        <p:nvSpPr>
-          <p:cNvPr id="33" name="TextBox 32"/>
-          <p:cNvSpPr txBox="1"/>
-          <p:nvPr/>
-        </p:nvSpPr>
-        <p:spPr>
-          <a:xfrm>
-            <a:off x="6309360" y="4233672"/>
-            <a:ext cx="1005840" cy="411480"/>
-          </a:xfrm>
-          <a:prstGeom prst="rect">
-            <a:avLst/>
-          </a:prstGeom>
-          <a:noFill/>
-        </p:spPr>
-        <p:txBody>
-          <a:bodyPr wrap="square" lIns="0" rIns="0" tIns="0" bIns="0">
-            <a:spAutoFit/>
-          </a:bodyPr>
-          <a:lstStyle/>
-          <a:p>
-            <a:pPr algn="ctr">
-              <a:lnSpc>
-                <a:spcPts val="2304"/>
-              </a:lnSpc>
-              <a:spcAft>
-                <a:spcPts val="0"/>
-              </a:spcAft>
-            </a:pPr>
-            <a:r>
-              <a:rPr sz="1800" b="0" i="0">
-                <a:solidFill>
-                  <a:srgbClr val="6B7480"/>
-                </a:solidFill>
-                <a:latin typeface="Garamond"/>
-              </a:rPr>
-              <a:t>→</a:t>
-            </a:r>
-          </a:p>
-        </p:txBody>
-      </p:sp>
-      <p:sp>
-        <p:nvSpPr>
-          <p:cNvPr id="34" name="TextBox 33"/>
-          <p:cNvSpPr txBox="1"/>
-          <p:nvPr/>
-        </p:nvSpPr>
-        <p:spPr>
-          <a:xfrm>
-            <a:off x="7223760" y="4233672"/>
-            <a:ext cx="1737360" cy="411480"/>
-          </a:xfrm>
-          <a:prstGeom prst="rect">
-            <a:avLst/>
-          </a:prstGeom>
-          <a:noFill/>
-        </p:spPr>
-        <p:txBody>
-          <a:bodyPr wrap="square" lIns="0" rIns="0" tIns="0" bIns="0">
-            <a:spAutoFit/>
-          </a:bodyPr>
-          <a:lstStyle/>
-          <a:p>
-            <a:pPr algn="ctr">
-              <a:lnSpc>
-                <a:spcPts val="2304"/>
-              </a:lnSpc>
-              <a:spcAft>
-                <a:spcPts val="0"/>
-              </a:spcAft>
-            </a:pPr>
-            <a:r>
-              <a:rPr sz="1800" b="1" i="0">
-                <a:solidFill>
-                  <a:srgbClr val="102D5E"/>
-                </a:solidFill>
-                <a:latin typeface="Garamond"/>
-              </a:rPr>
-              <a:t>2340</a:t>
-            </a:r>
-          </a:p>
-        </p:txBody>
-      </p:sp>
-      <p:sp>
-        <p:nvSpPr>
-          <p:cNvPr id="35" name="TextBox 34"/>
-          <p:cNvSpPr txBox="1"/>
-          <p:nvPr/>
-        </p:nvSpPr>
-        <p:spPr>
-          <a:xfrm>
-            <a:off x="8869680" y="4233672"/>
-            <a:ext cx="1005840" cy="411480"/>
-          </a:xfrm>
-          <a:prstGeom prst="rect">
-            <a:avLst/>
-          </a:prstGeom>
-          <a:noFill/>
-        </p:spPr>
-        <p:txBody>
-          <a:bodyPr wrap="square" lIns="0" rIns="0" tIns="0" bIns="0">
-            <a:spAutoFit/>
-          </a:bodyPr>
-          <a:lstStyle/>
-          <a:p>
-            <a:pPr algn="ctr">
-              <a:lnSpc>
-                <a:spcPts val="2304"/>
-              </a:lnSpc>
-              <a:spcAft>
-                <a:spcPts val="0"/>
-              </a:spcAft>
-            </a:pPr>
-            <a:r>
-              <a:rPr sz="1800" b="1" i="0">
-                <a:solidFill>
-                  <a:srgbClr val="8F2B36"/>
-                </a:solidFill>
-                <a:latin typeface="Garamond"/>
-              </a:rPr>
-              <a:t>→</a:t>
-            </a:r>
-          </a:p>
-        </p:txBody>
-      </p:sp>
-      <p:sp>
-        <p:nvSpPr>
-          <p:cNvPr id="36" name="TextBox 35"/>
-          <p:cNvSpPr txBox="1"/>
-          <p:nvPr/>
-        </p:nvSpPr>
-        <p:spPr>
-          <a:xfrm>
-            <a:off x="9784080" y="4233672"/>
-            <a:ext cx="1737360" cy="411480"/>
-          </a:xfrm>
-          <a:prstGeom prst="rect">
-            <a:avLst/>
-          </a:prstGeom>
-          <a:noFill/>
-        </p:spPr>
-        <p:txBody>
-          <a:bodyPr wrap="square" lIns="0" rIns="0" tIns="0" bIns="0">
-            <a:spAutoFit/>
-          </a:bodyPr>
-          <a:lstStyle/>
-          <a:p>
-            <a:pPr algn="ctr">
-              <a:lnSpc>
-                <a:spcPts val="2304"/>
-              </a:lnSpc>
-              <a:spcAft>
-                <a:spcPts val="0"/>
-              </a:spcAft>
-            </a:pPr>
-            <a:r>
-              <a:rPr sz="1800" b="1" i="0">
-                <a:solidFill>
-                  <a:srgbClr val="8F2B36"/>
-                </a:solidFill>
-                <a:latin typeface="Garamond"/>
-              </a:rPr>
-              <a:t>2360</a:t>
-            </a:r>
-          </a:p>
-        </p:txBody>
-      </p:sp>
-      <p:sp>
-        <p:nvSpPr>
-          <p:cNvPr id="37" name="TextBox 36"/>
-          <p:cNvSpPr txBox="1"/>
-          <p:nvPr/>
-        </p:nvSpPr>
-        <p:spPr>
-          <a:xfrm>
-            <a:off x="822960" y="5120640"/>
-            <a:ext cx="10789920" cy="914400"/>
-          </a:xfrm>
-          <a:prstGeom prst="rect">
-            <a:avLst/>
-          </a:prstGeom>
-          <a:noFill/>
-        </p:spPr>
-        <p:txBody>
-          <a:bodyPr wrap="square" lIns="0" rIns="0" tIns="0" bIns="0">
-            <a:spAutoFit/>
-          </a:bodyPr>
-          <a:lstStyle/>
-          <a:p>
-            <a:pPr algn="l">
-              <a:lnSpc>
-                <a:spcPts val="2304"/>
-              </a:lnSpc>
-              <a:spcAft>
-                <a:spcPts val="0"/>
-              </a:spcAft>
-            </a:pPr>
-            <a:r>
-              <a:rPr sz="1800" b="0" i="0">
-                <a:solidFill>
-                  <a:srgbClr val="212529"/>
-                </a:solidFill>
-                <a:latin typeface="Garamond"/>
-              </a:rPr>
-              <a:t>In 2003 every code changed but the five categories did not. In 2020 a single code changed. We always use the block, never a single code across regimes.</a:t>
-            </a:r>
-          </a:p>
-        </p:txBody>
-      </p:sp>
-      <p:sp>
-        <p:nvSpPr>
-          <p:cNvPr id="38" name="Rounded Rectangle 37">
+              <a:t>Our results are robust to this boundary: dropping special education teachers (d) and the residual category (e) moves the pooled leaving rate by 0.1 points (8.7 to 8.6).</a:t>
+            </a:r>
+          </a:p>
+        </p:txBody>
+      </p:sp>
+      <p:sp>
+        <p:nvSpPr>
+          <p:cNvPr id="7" name="Rounded Rectangle 6">
             <a:hlinkClick action="ppaction://hlinksldjump" r:id="rId2"/>
           </p:cNvPr>
           <p:cNvSpPr/>

</xml_diff>

<commit_message>
Harmonize codes robustness to the headline statistic: 8.6 vs 8.7 average
The codes appendix labelled pooled rates (8.57/8.67) while the main
evolution slide shows the 1997-2024 average of annual rates (8.6). Both
are now the same statistic: all five codes average 8.6, core three 8.7.
Updated the codes_narrow figure labels, the appendix key message, and
the robustness bullet on the codes slide in both decks and the
standalone file.

Co-Authored-By: Claude Fable 5 <noreply@anthropic.com>
Claude-Session: https://claude.ai/code/session_01DNzQPDcr3zfLTraMHUHqUn
</commit_message>
<xml_diff>
--- a/report/data_cluster/Proyect_US_cluster.pptx
+++ b/report/data_cluster/Proyect_US_cluster.pptx
@@ -20903,7 +20903,7 @@
                 </a:solidFill>
                 <a:latin typeface="Garamond"/>
               </a:rPr>
-              <a:t>Recomputing the whole series on the narrow core moves the pooled rate by 0.1 points. The 2003 and 2020 reclassifications leave no visible break.</a:t>
+              <a:t>Recomputing the whole series on the three core codes moves the 1997–2024 average from 8.6 to 8.7. The 2003 and 2020 reclassifications leave no visible break.</a:t>
             </a:r>
           </a:p>
         </p:txBody>
@@ -29096,7 +29096,7 @@
                 </a:solidFill>
                 <a:latin typeface="Garamond"/>
               </a:rPr>
-              <a:t>Our results are robust to this boundary: dropping special education teachers (d) and the residual category (e) moves the pooled leaving rate by 0.1 points (8.6 to 8.7).</a:t>
+              <a:t>Our results are robust to this boundary: dropping special education teachers (d) and the residual category (e) moves the 1997–2024 average leaving rate from 8.6 to 8.7.</a:t>
             </a:r>
           </a:p>
         </p:txBody>

</xml_diff>

<commit_message>
Reorder flow bars, gender-consistent palette, policy group definitions
Top bar now reads Employed, out of the labor force under 55, over 55,
unemployed in all four flow charts. Cascade groups use pinks for the
women's segments (women with no own child included) and blues for the
men's. New study_bygroup cascade replaces the study benchmark chart in
both decks. Policy slide heads carry each group's definition in
parentheses.

Co-Authored-By: Claude Fable 5 <noreply@anthropic.com>
Claude-Session: https://claude.ai/code/session_01DNzQPDcr3zfLTraMHUHqUn
</commit_message>
<xml_diff>
--- a/report/data_cluster/Proyect_US_cluster.pptx
+++ b/report/data_cluster/Proyect_US_cluster.pptx
@@ -10026,7 +10026,7 @@
       </p:sp>
       <p:pic>
         <p:nvPicPr>
-          <p:cNvPr id="4" name="Picture 3" descr="study_olf55.png"/>
+          <p:cNvPr id="4" name="Picture 3" descr="study_bygroup.png"/>
           <p:cNvPicPr>
             <a:picLocks noChangeAspect="1"/>
           </p:cNvPicPr>
@@ -10040,8 +10040,8 @@
         </p:blipFill>
         <p:spPr>
           <a:xfrm>
-            <a:off x="1184987" y="1051560"/>
-            <a:ext cx="9791544" cy="4526280"/>
+            <a:off x="1357685" y="1051560"/>
+            <a:ext cx="9446149" cy="4526280"/>
           </a:xfrm>
           <a:prstGeom prst="rect">
             <a:avLst/>
@@ -10094,7 +10094,7 @@
                 </a:solidFill>
                 <a:latin typeface="Garamond"/>
               </a:rPr>
-              <a:t>Leaving to study follows age, and teacher leavers mirror the typical graduate out of the labor force: 45% of those under 30 are enrolled in school, next to 60% among all graduates. After 40, almost none study.</a:t>
+              <a:t>Studying is the exit of the young and the childless, not of the mothers. Among leavers under 30, almost half are enrolled in school.</a:t>
             </a:r>
           </a:p>
         </p:txBody>
@@ -10221,7 +10221,16 @@
                 </a:solidFill>
                 <a:latin typeface="Garamond"/>
               </a:rPr>
-              <a:t>Retirees</a:t>
+              <a:t>Retirees </a:t>
+            </a:r>
+            <a:r>
+              <a:rPr sz="1800" b="0" i="0">
+                <a:solidFill>
+                  <a:srgbClr val="6B7480"/>
+                </a:solidFill>
+                <a:latin typeface="Garamond"/>
+              </a:rPr>
+              <a:t>(out of the labor force, over 55)</a:t>
             </a:r>
           </a:p>
         </p:txBody>
@@ -10305,7 +10314,16 @@
                 </a:solidFill>
                 <a:latin typeface="Garamond"/>
               </a:rPr>
-              <a:t>Switchers</a:t>
+              <a:t>Switchers </a:t>
+            </a:r>
+            <a:r>
+              <a:rPr sz="1800" b="0" i="0">
+                <a:solidFill>
+                  <a:srgbClr val="6B7480"/>
+                </a:solidFill>
+                <a:latin typeface="Garamond"/>
+              </a:rPr>
+              <a:t>(employed in another job)</a:t>
             </a:r>
           </a:p>
         </p:txBody>
@@ -10389,7 +10407,16 @@
                 </a:solidFill>
                 <a:latin typeface="Garamond"/>
               </a:rPr>
-              <a:t>Early exits</a:t>
+              <a:t>Early exits </a:t>
+            </a:r>
+            <a:r>
+              <a:rPr sz="1800" b="0" i="0">
+                <a:solidFill>
+                  <a:srgbClr val="6B7480"/>
+                </a:solidFill>
+                <a:latin typeface="Garamond"/>
+              </a:rPr>
+              <a:t>(out of the labor force, under 55)</a:t>
             </a:r>
           </a:p>
         </p:txBody>

</xml_diff>

<commit_message>
Clearer sample-loss line and verified ASEC household counts
Rewrite disadvantages B.2 as what-we-have vs what-we-would-have. Fix
the ASEC slide: about 70,000 interviewed households a year (78k in
2002, 56k in 2024), not 90,000 - that figure counts selected addresses
including vacants and nonresponse, verified against unique households
per survey year in the microdata.

Co-Authored-By: Claude Fable 5 <noreply@anthropic.com>
Claude-Session: https://claude.ai/code/session_01DNzQPDcr3zfLTraMHUHqUn
</commit_message>
<xml_diff>
--- a/report/data_cluster/Proyect_US_cluster.pptx
+++ b/report/data_cluster/Proyect_US_cluster.pptx
@@ -4661,7 +4661,7 @@
                 </a:solidFill>
                 <a:latin typeface="Garamond"/>
               </a:rPr>
-              <a:t>Less sample. The ASEC sees each teacher once a year, ~4,000 in all. The twelve monthly files see ~11,000 distinct teachers, about three times each. We give up two of every three teachers in exchange for the retrospective questions, which only March asks.</a:t>
+              <a:t>Less sample. Using only March, we observe ~4,000 teachers a year, once each. Using all twelve months we would observe ~11,000 teachers, three times each — but the retrospective questions that define the leaving rate are only asked in March.</a:t>
             </a:r>
           </a:p>
           <a:p>
@@ -28745,7 +28745,7 @@
                 </a:solidFill>
                 <a:latin typeface="Garamond"/>
               </a:rPr>
-              <a:t>About 90,000 households, counting the March sample plus oversamples interviewed in February and April.</a:t>
+              <a:t>About 70,000 interviewed households a year (78,000 in 2002, 56,000 in 2024): the March sample plus oversamples interviewed in February and April.</a:t>
             </a:r>
           </a:p>
           <a:p>

</xml_diff>

<commit_message>
Quantify the three panel-method losses on the disadvantages slide
Computed from the monthly panel (2015 and 2023 rotations): the
demographic validation discards ~5% of candidate links; ~17% of
validated teachers are never seen in year 2; 6-9% of due re-interviews
are missed each month. Internal migration (~8% of people move a year,
Census A-1) breaks address links and cannot be separated from refusals.

Co-Authored-By: Claude Fable 5 <noreply@anthropic.com>
Claude-Session: https://claude.ai/code/session_01DNzQPDcr3zfLTraMHUHqUn
</commit_message>
<xml_diff>
--- a/report/data_cluster/Proyect_US_cluster.pptx
+++ b/report/data_cluster/Proyect_US_cluster.pptx
@@ -4406,14 +4406,14 @@
           <a:p>
             <a:pPr algn="l">
               <a:lnSpc>
-                <a:spcPts val="2048"/>
-              </a:lnSpc>
-              <a:spcAft>
-                <a:spcPts val="1500"/>
-              </a:spcAft>
-            </a:pPr>
-            <a:r>
-              <a:rPr sz="1600" b="1" i="0">
+                <a:spcPts val="1920"/>
+              </a:lnSpc>
+              <a:spcAft>
+                <a:spcPts val="1300"/>
+              </a:spcAft>
+            </a:pPr>
+            <a:r>
+              <a:rPr sz="1500" b="1" i="0">
                 <a:solidFill>
                   <a:srgbClr val="2D6CB5"/>
                 </a:solidFill>
@@ -4422,26 +4422,26 @@
               <a:t>1.   </a:t>
             </a:r>
             <a:r>
-              <a:rPr sz="1600" b="0" i="0">
+              <a:rPr sz="1500" b="0" i="0">
                 <a:solidFill>
                   <a:srgbClr val="212529"/>
                 </a:solidFill>
                 <a:latin typeface="Garamond"/>
               </a:rPr>
-              <a:t>Identity is not certain, validation can admit noisy people.</a:t>
+              <a:t>Individual matching errors: the sex–race–age check discards ~5% of links; a same-profile replacement slipping through is not measurable.</a:t>
             </a:r>
           </a:p>
           <a:p>
             <a:pPr algn="l">
               <a:lnSpc>
-                <a:spcPts val="2048"/>
-              </a:lnSpc>
-              <a:spcAft>
-                <a:spcPts val="1500"/>
-              </a:spcAft>
-            </a:pPr>
-            <a:r>
-              <a:rPr sz="1600" b="1" i="0">
+                <a:spcPts val="1920"/>
+              </a:lnSpc>
+              <a:spcAft>
+                <a:spcPts val="1300"/>
+              </a:spcAft>
+            </a:pPr>
+            <a:r>
+              <a:rPr sz="1500" b="1" i="0">
                 <a:solidFill>
                   <a:srgbClr val="2D6CB5"/>
                 </a:solidFill>
@@ -4450,26 +4450,26 @@
               <a:t>2.   </a:t>
             </a:r>
             <a:r>
-              <a:rPr sz="1600" b="0" i="0">
+              <a:rPr sz="1500" b="0" i="0">
                 <a:solidFill>
                   <a:srgbClr val="212529"/>
                 </a:solidFill>
                 <a:latin typeface="Garamond"/>
               </a:rPr>
-              <a:t>Movers are lost. About 25% of addresses are not found a year later.</a:t>
+              <a:t>Internal migration: ~8% of people move home each year, and a move breaks the address link.</a:t>
             </a:r>
           </a:p>
           <a:p>
             <a:pPr algn="l">
               <a:lnSpc>
-                <a:spcPts val="2048"/>
-              </a:lnSpc>
-              <a:spcAft>
-                <a:spcPts val="1500"/>
-              </a:spcAft>
-            </a:pPr>
-            <a:r>
-              <a:rPr sz="1600" b="1" i="0">
+                <a:spcPts val="1920"/>
+              </a:lnSpc>
+              <a:spcAft>
+                <a:spcPts val="1300"/>
+              </a:spcAft>
+            </a:pPr>
+            <a:r>
+              <a:rPr sz="1500" b="1" i="0">
                 <a:solidFill>
                   <a:srgbClr val="2D6CB5"/>
                 </a:solidFill>
@@ -4478,26 +4478,26 @@
               <a:t>3.   </a:t>
             </a:r>
             <a:r>
-              <a:rPr sz="1600" b="0" i="0">
+              <a:rPr sz="1500" b="0" i="0">
                 <a:solidFill>
                   <a:srgbClr val="212529"/>
                 </a:solidFill>
                 <a:latin typeface="Garamond"/>
               </a:rPr>
-              <a:t>Normal household attrition on top.</a:t>
+              <a:t>Normal survey attrition: 6–9% of due re-interviews are missed each month; ~17% of teachers never reappear in year 2.</a:t>
             </a:r>
           </a:p>
           <a:p>
             <a:pPr algn="l">
               <a:lnSpc>
-                <a:spcPts val="2048"/>
-              </a:lnSpc>
-              <a:spcAft>
-                <a:spcPts val="1500"/>
-              </a:spcAft>
-            </a:pPr>
-            <a:r>
-              <a:rPr sz="1600" b="1" i="0">
+                <a:spcPts val="1920"/>
+              </a:lnSpc>
+              <a:spcAft>
+                <a:spcPts val="1300"/>
+              </a:spcAft>
+            </a:pPr>
+            <a:r>
+              <a:rPr sz="1500" b="1" i="0">
                 <a:solidFill>
                   <a:srgbClr val="2D6CB5"/>
                 </a:solidFill>
@@ -4506,7 +4506,7 @@
               <a:t>4.   </a:t>
             </a:r>
             <a:r>
-              <a:rPr sz="1600" b="0" i="0">
+              <a:rPr sz="1500" b="0" i="0">
                 <a:solidFill>
                   <a:srgbClr val="212529"/>
                 </a:solidFill>
@@ -4518,14 +4518,14 @@
           <a:p>
             <a:pPr algn="l">
               <a:lnSpc>
-                <a:spcPts val="2048"/>
-              </a:lnSpc>
-              <a:spcAft>
-                <a:spcPts val="0"/>
-              </a:spcAft>
-            </a:pPr>
-            <a:r>
-              <a:rPr sz="1600" b="1" i="0">
+                <a:spcPts val="1920"/>
+              </a:lnSpc>
+              <a:spcAft>
+                <a:spcPts val="0"/>
+              </a:spcAft>
+            </a:pPr>
+            <a:r>
+              <a:rPr sz="1500" b="1" i="0">
                 <a:solidFill>
                   <a:srgbClr val="2D6CB5"/>
                 </a:solidFill>
@@ -4534,7 +4534,7 @@
               <a:t>5.   </a:t>
             </a:r>
             <a:r>
-              <a:rPr sz="1600" b="0" i="0">
+              <a:rPr sz="1500" b="0" i="0">
                 <a:solidFill>
                   <a:srgbClr val="212529"/>
                 </a:solidFill>

</xml_diff>

<commit_message>
Clean decomposition of panel losses: moves vs pure survey attrition
Split the year-2 loss at the address level: the address responds but
the person has moved (~8% a year, matching the Census mover rate) vs
the address never responds again (pure survey attrition, 7% in 2015
and 12% in 2023, ~10% on average). Slide bullets updated with the
clean numbers.

Co-Authored-By: Claude Fable 5 <noreply@anthropic.com>
Claude-Session: https://claude.ai/code/session_01DNzQPDcr3zfLTraMHUHqUn
</commit_message>
<xml_diff>
--- a/report/data_cluster/Proyect_US_cluster.pptx
+++ b/report/data_cluster/Proyect_US_cluster.pptx
@@ -4456,7 +4456,7 @@
                 </a:solidFill>
                 <a:latin typeface="Garamond"/>
               </a:rPr>
-              <a:t>Internal migration: ~8% of people move home each year, and a move breaks the address link.</a:t>
+              <a:t>Internal migration: ~8% a year — the address responds but the person has moved (the Census mover rate is 8%).</a:t>
             </a:r>
           </a:p>
           <a:p>
@@ -4484,7 +4484,7 @@
                 </a:solidFill>
                 <a:latin typeface="Garamond"/>
               </a:rPr>
-              <a:t>Normal survey attrition: 6–9% of due re-interviews are missed each month; ~17% of teachers never reappear in year 2.</a:t>
+              <a:t>Normal survey attrition: ~10% a year — the address is due for re-interview but never responds again (7% in 2015, 12% in 2023).</a:t>
             </a:r>
           </a:p>
           <a:p>

</xml_diff>

<commit_message>
Life-cycle slide: message states the policy implication, not the chart
Co-Authored-By: Claude Fable 5 <noreply@anthropic.com>
Claude-Session: https://claude.ai/code/session_01DNzQPDcr3zfLTraMHUHqUn
</commit_message>
<xml_diff>
--- a/report/data_cluster/Proyect_US_cluster.pptx
+++ b/report/data_cluster/Proyect_US_cluster.pptx
@@ -10596,14 +10596,14 @@
           <a:p>
             <a:pPr algn="l">
               <a:lnSpc>
-                <a:spcPts val="2048"/>
-              </a:lnSpc>
-              <a:spcAft>
-                <a:spcPts val="0"/>
-              </a:spcAft>
-            </a:pPr>
-            <a:r>
-              <a:rPr sz="1600" b="1" i="0">
+                <a:spcPts val="1855"/>
+              </a:lnSpc>
+              <a:spcAft>
+                <a:spcPts val="0"/>
+              </a:spcAft>
+            </a:pPr>
+            <a:r>
+              <a:rPr sz="1450" b="1" i="0">
                 <a:solidFill>
                   <a:srgbClr val="102D5E"/>
                 </a:solidFill>
@@ -10612,13 +10612,13 @@
               <a:t>Key message.  </a:t>
             </a:r>
             <a:r>
-              <a:rPr sz="1600" b="0" i="0">
+              <a:rPr sz="1450" b="0" i="0">
                 <a:solidFill>
                   <a:srgbClr val="212529"/>
                 </a:solidFill>
                 <a:latin typeface="Garamond"/>
               </a:rPr>
-              <a:t>The risk of leaving is highest at the two ends of the career. The young leave for other jobs; the old leave the labor force.</a:t>
+              <a:t>The two peaks call for different levers: the young trade teaching for other jobs — a retention problem (mentorship, secure placements, early-career conditions); the old leave the labor force — a timing problem (extending careers). Re-attraction can only work on the first.</a:t>
             </a:r>
           </a:p>
         </p:txBody>

</xml_diff>

<commit_message>
Tighter life-cycle key message
Co-Authored-By: Claude Fable 5 <noreply@anthropic.com>
Claude-Session: https://claude.ai/code/session_01DNzQPDcr3zfLTraMHUHqUn
</commit_message>
<xml_diff>
--- a/report/data_cluster/Proyect_US_cluster.pptx
+++ b/report/data_cluster/Proyect_US_cluster.pptx
@@ -10596,14 +10596,14 @@
           <a:p>
             <a:pPr algn="l">
               <a:lnSpc>
-                <a:spcPts val="1855"/>
-              </a:lnSpc>
-              <a:spcAft>
-                <a:spcPts val="0"/>
-              </a:spcAft>
-            </a:pPr>
-            <a:r>
-              <a:rPr sz="1450" b="1" i="0">
+                <a:spcPts val="2048"/>
+              </a:lnSpc>
+              <a:spcAft>
+                <a:spcPts val="0"/>
+              </a:spcAft>
+            </a:pPr>
+            <a:r>
+              <a:rPr sz="1600" b="1" i="0">
                 <a:solidFill>
                   <a:srgbClr val="102D5E"/>
                 </a:solidFill>
@@ -10612,13 +10612,13 @@
               <a:t>Key message.  </a:t>
             </a:r>
             <a:r>
-              <a:rPr sz="1450" b="0" i="0">
+              <a:rPr sz="1600" b="0" i="0">
                 <a:solidFill>
                   <a:srgbClr val="212529"/>
                 </a:solidFill>
                 <a:latin typeface="Garamond"/>
               </a:rPr>
-              <a:t>The two peaks call for different levers: the young trade teaching for other jobs — a retention problem (mentorship, secure placements, early-career conditions); the old leave the labor force — a timing problem (extending careers). Re-attraction can only work on the first.</a:t>
+              <a:t>Each peak needs its own lever: retention for the young, who leave for other jobs; career extension for the old, who retire.</a:t>
             </a:r>
           </a:p>
         </p:txBody>

</xml_diff>

<commit_message>
Restructured Contribution slide: one source, no gaps, beyond the rate
Co-Authored-By: Claude Fable 5 <noreply@anthropic.com>
Claude-Session: https://claude.ai/code/session_01DNzQPDcr3zfLTraMHUHqUn
</commit_message>
<xml_diff>
--- a/report/data_cluster/Proyect_US_cluster.pptx
+++ b/report/data_cluster/Proyect_US_cluster.pptx
@@ -12014,8 +12014,8 @@
         </p:nvSpPr>
         <p:spPr>
           <a:xfrm>
-            <a:off x="822960" y="1600200"/>
-            <a:ext cx="10789920" cy="548640"/>
+            <a:off x="822960" y="1417320"/>
+            <a:ext cx="10789920" cy="822960"/>
           </a:xfrm>
           <a:prstGeom prst="rect">
             <a:avLst/>
@@ -12043,7 +12043,7 @@
                 </a:solidFill>
                 <a:latin typeface="Garamond"/>
               </a:rPr>
-              <a:t>We use the Current Population Survey to</a:t>
+              <a:t>We build one of the longest continuous measures of teacher attrition in the United States: twenty-eight consecutive years, 1998–2025.</a:t>
             </a:r>
           </a:p>
         </p:txBody>
@@ -12056,7 +12056,7 @@
         </p:nvSpPr>
         <p:spPr>
           <a:xfrm>
-            <a:off x="822960" y="2788920"/>
+            <a:off x="822960" y="2743200"/>
             <a:ext cx="10789920" cy="5120640"/>
           </a:xfrm>
           <a:prstGeom prst="rect">
@@ -12072,57 +12072,112 @@
           <a:p>
             <a:pPr algn="l">
               <a:lnSpc>
-                <a:spcPts val="2816"/>
-              </a:lnSpc>
-              <a:spcAft>
-                <a:spcPts val="4400"/>
-              </a:spcAft>
-            </a:pPr>
-            <a:r>
-              <a:rPr sz="2200" b="1" i="0">
+                <a:spcPts val="2560"/>
+              </a:lnSpc>
+              <a:spcAft>
+                <a:spcPts val="3000"/>
+              </a:spcAft>
+            </a:pPr>
+            <a:r>
+              <a:rPr sz="2000" b="1" i="0">
                 <a:solidFill>
                   <a:srgbClr val="2D6CB5"/>
                 </a:solidFill>
                 <a:latin typeface="Garamond"/>
               </a:rPr>
-              <a:t>1.   </a:t>
-            </a:r>
-            <a:r>
-              <a:rPr sz="2200" b="0" i="0">
+              <a:t>▪  </a:t>
+            </a:r>
+            <a:r>
+              <a:rPr sz="2000" b="1" i="0">
+                <a:solidFill>
+                  <a:srgbClr val="102D5E"/>
+                </a:solidFill>
+                <a:latin typeface="Garamond"/>
+              </a:rPr>
+              <a:t>One source.  </a:t>
+            </a:r>
+            <a:r>
+              <a:rPr sz="2000" b="0" i="0">
                 <a:solidFill>
                   <a:srgbClr val="212529"/>
                 </a:solidFill>
                 <a:latin typeface="Garamond"/>
               </a:rPr>
-              <a:t>reproduce and extend the official statistics on teachers leaving the profession;</a:t>
+              <a:t>Every number comes from the same instrument — the CPS March supplement — under a single definition, with no splicing of surveys.</a:t>
             </a:r>
           </a:p>
           <a:p>
             <a:pPr algn="l">
               <a:lnSpc>
-                <a:spcPts val="2816"/>
-              </a:lnSpc>
-              <a:spcAft>
-                <a:spcPts val="0"/>
-              </a:spcAft>
-            </a:pPr>
-            <a:r>
-              <a:rPr sz="2200" b="1" i="0">
+                <a:spcPts val="2560"/>
+              </a:lnSpc>
+              <a:spcAft>
+                <a:spcPts val="3000"/>
+              </a:spcAft>
+            </a:pPr>
+            <a:r>
+              <a:rPr sz="2000" b="1" i="0">
                 <a:solidFill>
                   <a:srgbClr val="2D6CB5"/>
                 </a:solidFill>
                 <a:latin typeface="Garamond"/>
               </a:rPr>
-              <a:t>2.   </a:t>
-            </a:r>
-            <a:r>
-              <a:rPr sz="2200" b="0" i="0">
+              <a:t>▪  </a:t>
+            </a:r>
+            <a:r>
+              <a:rPr sz="2000" b="1" i="0">
+                <a:solidFill>
+                  <a:srgbClr val="102D5E"/>
+                </a:solidFill>
+                <a:latin typeface="Garamond"/>
+              </a:rPr>
+              <a:t>No gaps.  </a:t>
+            </a:r>
+            <a:r>
+              <a:rPr sz="2000" b="0" i="0">
                 <a:solidFill>
                   <a:srgbClr val="212529"/>
                 </a:solidFill>
                 <a:latin typeface="Garamond"/>
               </a:rPr>
-              <a:t>having achieved A, study in detail how many leave, where they go, and why.</a:t>
+              <a:t>Twenty-eight consecutive annual observations; the official benchmark measures once every four or more years.</a:t>
+            </a:r>
+          </a:p>
+          <a:p>
+            <a:pPr algn="l">
+              <a:lnSpc>
+                <a:spcPts val="2560"/>
+              </a:lnSpc>
+              <a:spcAft>
+                <a:spcPts val="0"/>
+              </a:spcAft>
+            </a:pPr>
+            <a:r>
+              <a:rPr sz="2000" b="1" i="0">
+                <a:solidFill>
+                  <a:srgbClr val="2D6CB5"/>
+                </a:solidFill>
+                <a:latin typeface="Garamond"/>
+              </a:rPr>
+              <a:t>▪  </a:t>
+            </a:r>
+            <a:r>
+              <a:rPr sz="2000" b="1" i="0">
+                <a:solidFill>
+                  <a:srgbClr val="102D5E"/>
+                </a:solidFill>
+                <a:latin typeface="Garamond"/>
+              </a:rPr>
+              <a:t>Beyond the rate.  </a:t>
+            </a:r>
+            <a:r>
+              <a:rPr sz="2000" b="0" i="0">
+                <a:solidFill>
+                  <a:srgbClr val="212529"/>
+                </a:solidFill>
+                <a:latin typeface="Garamond"/>
+              </a:rPr>
+              <a:t>The same files show who leaves, where they go, what leaving pays, who returns, and what moves the rate.</a:t>
             </a:r>
           </a:p>
         </p:txBody>

</xml_diff>

<commit_message>
Academic one-line Contribution bullets
Co-Authored-By: Claude Fable 5 <noreply@anthropic.com>
Claude-Session: https://claude.ai/code/session_01DNzQPDcr3zfLTraMHUHqUn
</commit_message>
<xml_diff>
--- a/report/data_cluster/Proyect_US_cluster.pptx
+++ b/report/data_cluster/Proyect_US_cluster.pptx
@@ -12043,7 +12043,7 @@
                 </a:solidFill>
                 <a:latin typeface="Garamond"/>
               </a:rPr>
-              <a:t>We build one of the longest continuous measures of teacher attrition in the United States: twenty-eight consecutive years, 1998–2025.</a:t>
+              <a:t>We build one of the longest continuous measures of teacher attrition in the United States, twenty-eight consecutive years (1998–2025).</a:t>
             </a:r>
           </a:p>
         </p:txBody>
@@ -12103,7 +12103,7 @@
                 </a:solidFill>
                 <a:latin typeface="Garamond"/>
               </a:rPr>
-              <a:t>Every number comes from the same instrument — the CPS March supplement — under a single definition, with no splicing of surveys.</a:t>
+              <a:t>A single instrument and a single definition over the whole period.</a:t>
             </a:r>
           </a:p>
           <a:p>
@@ -12140,7 +12140,7 @@
                 </a:solidFill>
                 <a:latin typeface="Garamond"/>
               </a:rPr>
-              <a:t>Twenty-eight consecutive annual observations; the official benchmark measures once every four or more years.</a:t>
+              <a:t>Twenty-eight consecutive years against a quadrennial official benchmark.</a:t>
             </a:r>
           </a:p>
           <a:p>
@@ -12177,7 +12177,7 @@
                 </a:solidFill>
                 <a:latin typeface="Garamond"/>
               </a:rPr>
-              <a:t>The same files show who leaves, where they go, what leaving pays, who returns, and what moves the rate.</a:t>
+              <a:t>Who leaves, where they go, and what leaving pays.</a:t>
             </a:r>
           </a:p>
         </p:txBody>

</xml_diff>

<commit_message>
Counselors pay from 2002 and determinants slide as an enumeration
The relative-pay panel now starts the counselors series in calendar
2002 (the pre-2003 occupation code is too narrow), rebased to 2002=100
and labeled as such, matching the leaving-rate chart. The determinants
appendix slide drops the yes/no table for a grouped enumeration with a
line crediting the policy paper's initial literature review; added the
standalone determinants_slide.pptx. Both decks rebuilt.

Co-Authored-By: Claude Fable 5 <noreply@anthropic.com>
Claude-Session: https://claude.ai/code/session_01DNzQPDcr3zfLTraMHUHqUn
</commit_message>
<xml_diff>
--- a/report/data_cluster/Proyect_US_cluster.pptx
+++ b/report/data_cluster/Proyect_US_cluster.pptx
@@ -27805,7 +27805,7 @@
                 </a:solidFill>
                 <a:latin typeface="Garamond"/>
               </a:rPr>
-              <a:t>What the CPS observes, of why teachers leave</a:t>
+              <a:t>Determinants of leaving the teaching profession</a:t>
             </a:r>
           </a:p>
         </p:txBody>
@@ -27845,42 +27845,48 @@
           </a:p>
         </p:txBody>
       </p:sp>
-      <p:cxnSp>
-        <p:nvCxnSpPr>
-          <p:cNvPr id="4" name="Connector 3"/>
-          <p:cNvCxnSpPr/>
-          <p:nvPr/>
-        </p:nvCxnSpPr>
-        <p:spPr>
-          <a:xfrm>
-            <a:off x="822960" y="1645920"/>
-            <a:ext cx="10241280" cy="0"/>
-          </a:xfrm>
-          <a:prstGeom prst="line">
-            <a:avLst/>
-          </a:prstGeom>
-          <a:ln w="16510">
-            <a:solidFill>
-              <a:srgbClr val="212529"/>
-            </a:solidFill>
-          </a:ln>
-          <a:effectLst/>
-        </p:spPr>
-        <p:style>
-          <a:lnRef idx="2">
-            <a:schemeClr val="accent1"/>
-          </a:lnRef>
-          <a:fillRef idx="0">
-            <a:schemeClr val="accent1"/>
-          </a:fillRef>
-          <a:effectRef idx="1">
-            <a:schemeClr val="accent1"/>
-          </a:effectRef>
-          <a:fontRef idx="minor">
-            <a:schemeClr val="tx1"/>
-          </a:fontRef>
-        </p:style>
-      </p:cxnSp>
+      <p:sp>
+        <p:nvSpPr>
+          <p:cNvPr id="4" name="TextBox 3"/>
+          <p:cNvSpPr txBox="1"/>
+          <p:nvPr/>
+        </p:nvSpPr>
+        <p:spPr>
+          <a:xfrm>
+            <a:off x="822960" y="1115568"/>
+            <a:ext cx="10789920" cy="365760"/>
+          </a:xfrm>
+          <a:prstGeom prst="rect">
+            <a:avLst/>
+          </a:prstGeom>
+          <a:noFill/>
+        </p:spPr>
+        <p:txBody>
+          <a:bodyPr wrap="square" lIns="0" rIns="0" tIns="0" bIns="0">
+            <a:spAutoFit/>
+          </a:bodyPr>
+          <a:lstStyle/>
+          <a:p>
+            <a:pPr algn="l">
+              <a:lnSpc>
+                <a:spcPts val="1920"/>
+              </a:lnSpc>
+              <a:spcAft>
+                <a:spcPts val="0"/>
+              </a:spcAft>
+            </a:pPr>
+            <a:r>
+              <a:rPr sz="1500" b="0" i="1">
+                <a:solidFill>
+                  <a:srgbClr val="6B7480"/>
+                </a:solidFill>
+                <a:latin typeface="Garamond"/>
+              </a:rPr>
+              <a:t>From the initial literature review of our policy paper</a:t>
+            </a:r>
+          </a:p>
+        </p:txBody>
+      </p:sp>
       <p:sp>
         <p:nvSpPr>
           <p:cNvPr id="5" name="TextBox 4"/>
@@ -27889,8 +27895,8 @@
         </p:nvSpPr>
         <p:spPr>
           <a:xfrm>
-            <a:off x="822960" y="1755648"/>
-            <a:ext cx="6949440" cy="420624"/>
+            <a:off x="822960" y="1847088"/>
+            <a:ext cx="10789920" cy="365760"/>
           </a:xfrm>
           <a:prstGeom prst="rect">
             <a:avLst/>
@@ -27905,102 +27911,200 @@
           <a:p>
             <a:pPr algn="l">
               <a:lnSpc>
-                <a:spcPts val="2048"/>
-              </a:lnSpc>
-              <a:spcAft>
-                <a:spcPts val="0"/>
-              </a:spcAft>
-            </a:pPr>
-            <a:r>
-              <a:rPr sz="1600" b="1" i="0">
+                <a:spcPts val="2432"/>
+              </a:lnSpc>
+              <a:spcAft>
+                <a:spcPts val="0"/>
+              </a:spcAft>
+            </a:pPr>
+            <a:r>
+              <a:rPr sz="1900" b="1" i="0">
+                <a:solidFill>
+                  <a:srgbClr val="6B7480"/>
+                </a:solidFill>
+                <a:latin typeface="Garamond"/>
+              </a:rPr>
+              <a:t>In the literature, but not in the CPS</a:t>
+            </a:r>
+          </a:p>
+        </p:txBody>
+      </p:sp>
+      <p:sp>
+        <p:nvSpPr>
+          <p:cNvPr id="6" name="TextBox 5"/>
+          <p:cNvSpPr txBox="1"/>
+          <p:nvPr/>
+        </p:nvSpPr>
+        <p:spPr>
+          <a:xfrm>
+            <a:off x="822960" y="2359152"/>
+            <a:ext cx="10789920" cy="5120640"/>
+          </a:xfrm>
+          <a:prstGeom prst="rect">
+            <a:avLst/>
+          </a:prstGeom>
+          <a:noFill/>
+        </p:spPr>
+        <p:txBody>
+          <a:bodyPr wrap="square" lIns="0" rIns="0" tIns="0" bIns="0">
+            <a:spAutoFit/>
+          </a:bodyPr>
+          <a:lstStyle/>
+          <a:p>
+            <a:pPr algn="l">
+              <a:lnSpc>
+                <a:spcPts val="2176"/>
+              </a:lnSpc>
+              <a:spcAft>
+                <a:spcPts val="1200"/>
+              </a:spcAft>
+            </a:pPr>
+            <a:r>
+              <a:rPr sz="1700" b="1" i="0">
+                <a:solidFill>
+                  <a:srgbClr val="6B7480"/>
+                </a:solidFill>
+                <a:latin typeface="Garamond"/>
+              </a:rPr>
+              <a:t>▪  </a:t>
+            </a:r>
+            <a:r>
+              <a:rPr sz="1700" b="1" i="0">
+                <a:solidFill>
+                  <a:srgbClr val="102D5E"/>
+                </a:solidFill>
+                <a:latin typeface="Garamond"/>
+              </a:rPr>
+              <a:t>Working conditions.  </a:t>
+            </a:r>
+            <a:r>
+              <a:rPr sz="1700" b="0" i="0">
                 <a:solidFill>
                   <a:srgbClr val="212529"/>
                 </a:solidFill>
                 <a:latin typeface="Garamond"/>
               </a:rPr>
-              <a:t>Reasons in the literature</a:t>
-            </a:r>
-          </a:p>
-        </p:txBody>
-      </p:sp>
-      <p:sp>
-        <p:nvSpPr>
-          <p:cNvPr id="6" name="TextBox 5"/>
-          <p:cNvSpPr txBox="1"/>
-          <p:nvPr/>
-        </p:nvSpPr>
-        <p:spPr>
-          <a:xfrm>
-            <a:off x="7955279" y="1755648"/>
-            <a:ext cx="3108960" cy="420624"/>
-          </a:xfrm>
-          <a:prstGeom prst="rect">
-            <a:avLst/>
-          </a:prstGeom>
-          <a:noFill/>
-        </p:spPr>
-        <p:txBody>
-          <a:bodyPr wrap="square" lIns="0" rIns="0" tIns="0" bIns="0">
-            <a:spAutoFit/>
-          </a:bodyPr>
-          <a:lstStyle/>
+              <a:t>Workload, class size, and student behavior.</a:t>
+            </a:r>
+          </a:p>
           <a:p>
             <a:pPr algn="l">
               <a:lnSpc>
-                <a:spcPts val="2048"/>
-              </a:lnSpc>
-              <a:spcAft>
-                <a:spcPts val="0"/>
-              </a:spcAft>
-            </a:pPr>
-            <a:r>
-              <a:rPr sz="1600" b="1" i="0">
+                <a:spcPts val="2176"/>
+              </a:lnSpc>
+              <a:spcAft>
+                <a:spcPts val="1200"/>
+              </a:spcAft>
+            </a:pPr>
+            <a:r>
+              <a:rPr sz="1700" b="1" i="0">
+                <a:solidFill>
+                  <a:srgbClr val="6B7480"/>
+                </a:solidFill>
+                <a:latin typeface="Garamond"/>
+              </a:rPr>
+              <a:t>▪  </a:t>
+            </a:r>
+            <a:r>
+              <a:rPr sz="1700" b="1" i="0">
+                <a:solidFill>
+                  <a:srgbClr val="102D5E"/>
+                </a:solidFill>
+                <a:latin typeface="Garamond"/>
+              </a:rPr>
+              <a:t>Organizational support.  </a:t>
+            </a:r>
+            <a:r>
+              <a:rPr sz="1700" b="0" i="0">
                 <a:solidFill>
                   <a:srgbClr val="212529"/>
                 </a:solidFill>
                 <a:latin typeface="Garamond"/>
               </a:rPr>
-              <a:t>In the CPS?</a:t>
-            </a:r>
-          </a:p>
-        </p:txBody>
-      </p:sp>
-      <p:cxnSp>
-        <p:nvCxnSpPr>
-          <p:cNvPr id="7" name="Connector 6"/>
-          <p:cNvCxnSpPr/>
-          <p:nvPr/>
-        </p:nvCxnSpPr>
-        <p:spPr>
-          <a:xfrm>
-            <a:off x="822960" y="2194560"/>
-            <a:ext cx="10241280" cy="0"/>
-          </a:xfrm>
-          <a:prstGeom prst="line">
-            <a:avLst/>
-          </a:prstGeom>
-          <a:ln w="8890">
-            <a:solidFill>
-              <a:srgbClr val="212529"/>
-            </a:solidFill>
-          </a:ln>
-          <a:effectLst/>
-        </p:spPr>
-        <p:style>
-          <a:lnRef idx="2">
-            <a:schemeClr val="accent1"/>
-          </a:lnRef>
-          <a:fillRef idx="0">
-            <a:schemeClr val="accent1"/>
-          </a:fillRef>
-          <a:effectRef idx="1">
-            <a:schemeClr val="accent1"/>
-          </a:effectRef>
-          <a:fontRef idx="minor">
-            <a:schemeClr val="tx1"/>
-          </a:fontRef>
-        </p:style>
-      </p:cxnSp>
+              <a:t>Leadership, mentoring, and school climate.</a:t>
+            </a:r>
+          </a:p>
+          <a:p>
+            <a:pPr algn="l">
+              <a:lnSpc>
+                <a:spcPts val="2176"/>
+              </a:lnSpc>
+              <a:spcAft>
+                <a:spcPts val="0"/>
+              </a:spcAft>
+            </a:pPr>
+            <a:r>
+              <a:rPr sz="1700" b="1" i="0">
+                <a:solidFill>
+                  <a:srgbClr val="6B7480"/>
+                </a:solidFill>
+                <a:latin typeface="Garamond"/>
+              </a:rPr>
+              <a:t>▪  </a:t>
+            </a:r>
+            <a:r>
+              <a:rPr sz="1700" b="1" i="0">
+                <a:solidFill>
+                  <a:srgbClr val="102D5E"/>
+                </a:solidFill>
+                <a:latin typeface="Garamond"/>
+              </a:rPr>
+              <a:t>Autonomy and intrinsic motives.  </a:t>
+            </a:r>
+            <a:r>
+              <a:rPr sz="1700" b="0" i="0">
+                <a:solidFill>
+                  <a:srgbClr val="212529"/>
+                </a:solidFill>
+                <a:latin typeface="Garamond"/>
+              </a:rPr>
+              <a:t>Control over one's own work and the sense of vocation.</a:t>
+            </a:r>
+          </a:p>
+        </p:txBody>
+      </p:sp>
+      <p:sp>
+        <p:nvSpPr>
+          <p:cNvPr id="7" name="TextBox 6"/>
+          <p:cNvSpPr txBox="1"/>
+          <p:nvPr/>
+        </p:nvSpPr>
+        <p:spPr>
+          <a:xfrm>
+            <a:off x="822960" y="4041648"/>
+            <a:ext cx="10789920" cy="365760"/>
+          </a:xfrm>
+          <a:prstGeom prst="rect">
+            <a:avLst/>
+          </a:prstGeom>
+          <a:noFill/>
+        </p:spPr>
+        <p:txBody>
+          <a:bodyPr wrap="square" lIns="0" rIns="0" tIns="0" bIns="0">
+            <a:spAutoFit/>
+          </a:bodyPr>
+          <a:lstStyle/>
+          <a:p>
+            <a:pPr algn="l">
+              <a:lnSpc>
+                <a:spcPts val="2432"/>
+              </a:lnSpc>
+              <a:spcAft>
+                <a:spcPts val="0"/>
+              </a:spcAft>
+            </a:pPr>
+            <a:r>
+              <a:rPr sz="1900" b="1" i="0">
+                <a:solidFill>
+                  <a:srgbClr val="102D5E"/>
+                </a:solidFill>
+                <a:latin typeface="Garamond"/>
+              </a:rPr>
+              <a:t>What the CPS observes</a:t>
+            </a:r>
+          </a:p>
+        </p:txBody>
+      </p:sp>
       <p:sp>
         <p:nvSpPr>
           <p:cNvPr id="8" name="TextBox 7"/>
@@ -28009,8 +28113,8 @@
         </p:nvSpPr>
         <p:spPr>
           <a:xfrm>
-            <a:off x="822960" y="2304288"/>
-            <a:ext cx="6949440" cy="420624"/>
+            <a:off x="822960" y="4553712"/>
+            <a:ext cx="10789920" cy="5120640"/>
           </a:xfrm>
           <a:prstGeom prst="rect">
             <a:avLst/>
@@ -28025,561 +28129,119 @@
           <a:p>
             <a:pPr algn="l">
               <a:lnSpc>
-                <a:spcPts val="2048"/>
-              </a:lnSpc>
-              <a:spcAft>
-                <a:spcPts val="0"/>
-              </a:spcAft>
-            </a:pPr>
-            <a:r>
-              <a:rPr sz="1600" b="0" i="0">
+                <a:spcPts val="2176"/>
+              </a:lnSpc>
+              <a:spcAft>
+                <a:spcPts val="1200"/>
+              </a:spcAft>
+            </a:pPr>
+            <a:r>
+              <a:rPr sz="1700" b="1" i="0">
+                <a:solidFill>
+                  <a:srgbClr val="2D6CB5"/>
+                </a:solidFill>
+                <a:latin typeface="Garamond"/>
+              </a:rPr>
+              <a:t>▪  </a:t>
+            </a:r>
+            <a:r>
+              <a:rPr sz="1700" b="1" i="0">
+                <a:solidFill>
+                  <a:srgbClr val="102D5E"/>
+                </a:solidFill>
+                <a:latin typeface="Garamond"/>
+              </a:rPr>
+              <a:t>Financial factors.  </a:t>
+            </a:r>
+            <a:r>
+              <a:rPr sz="1700" b="0" i="0">
                 <a:solidFill>
                   <a:srgbClr val="212529"/>
                 </a:solidFill>
                 <a:latin typeface="Garamond"/>
               </a:rPr>
-              <a:t>Working conditions</a:t>
-            </a:r>
-          </a:p>
-        </p:txBody>
-      </p:sp>
-      <p:sp>
-        <p:nvSpPr>
-          <p:cNvPr id="9" name="TextBox 8"/>
-          <p:cNvSpPr txBox="1"/>
-          <p:nvPr/>
-        </p:nvSpPr>
-        <p:spPr>
-          <a:xfrm>
-            <a:off x="7955279" y="2304288"/>
-            <a:ext cx="3108960" cy="420624"/>
-          </a:xfrm>
-          <a:prstGeom prst="rect">
-            <a:avLst/>
-          </a:prstGeom>
-          <a:noFill/>
-        </p:spPr>
-        <p:txBody>
-          <a:bodyPr wrap="square" lIns="0" rIns="0" tIns="0" bIns="0">
-            <a:spAutoFit/>
-          </a:bodyPr>
-          <a:lstStyle/>
+              <a:t>Own earnings, household income, and the pay of the outside options.</a:t>
+            </a:r>
+          </a:p>
           <a:p>
             <a:pPr algn="l">
               <a:lnSpc>
-                <a:spcPts val="2048"/>
-              </a:lnSpc>
-              <a:spcAft>
-                <a:spcPts val="0"/>
-              </a:spcAft>
-            </a:pPr>
-            <a:r>
-              <a:rPr sz="1600" b="0" i="0">
-                <a:solidFill>
-                  <a:srgbClr val="6B7480"/>
-                </a:solidFill>
-                <a:latin typeface="Garamond"/>
-              </a:rPr>
-              <a:t>no</a:t>
-            </a:r>
-          </a:p>
-        </p:txBody>
-      </p:sp>
-      <p:sp>
-        <p:nvSpPr>
-          <p:cNvPr id="10" name="TextBox 9"/>
-          <p:cNvSpPr txBox="1"/>
-          <p:nvPr/>
-        </p:nvSpPr>
-        <p:spPr>
-          <a:xfrm>
-            <a:off x="822960" y="2724912"/>
-            <a:ext cx="6949440" cy="420624"/>
-          </a:xfrm>
-          <a:prstGeom prst="rect">
-            <a:avLst/>
-          </a:prstGeom>
-          <a:noFill/>
-        </p:spPr>
-        <p:txBody>
-          <a:bodyPr wrap="square" lIns="0" rIns="0" tIns="0" bIns="0">
-            <a:spAutoFit/>
-          </a:bodyPr>
-          <a:lstStyle/>
+                <a:spcPts val="2176"/>
+              </a:lnSpc>
+              <a:spcAft>
+                <a:spcPts val="1200"/>
+              </a:spcAft>
+            </a:pPr>
+            <a:r>
+              <a:rPr sz="1700" b="1" i="0">
+                <a:solidFill>
+                  <a:srgbClr val="2D6CB5"/>
+                </a:solidFill>
+                <a:latin typeface="Garamond"/>
+              </a:rPr>
+              <a:t>▪  </a:t>
+            </a:r>
+            <a:r>
+              <a:rPr sz="1700" b="1" i="0">
+                <a:solidFill>
+                  <a:srgbClr val="102D5E"/>
+                </a:solidFill>
+                <a:latin typeface="Garamond"/>
+              </a:rPr>
+              <a:t>Personal life-cycle motives.  </a:t>
+            </a:r>
+            <a:r>
+              <a:rPr sz="1700" b="0" i="0">
+                <a:solidFill>
+                  <a:srgbClr val="212529"/>
+                </a:solidFill>
+                <a:latin typeface="Garamond"/>
+              </a:rPr>
+              <a:t>Marriage, children, health, and retirement timing.</a:t>
+            </a:r>
+          </a:p>
           <a:p>
             <a:pPr algn="l">
               <a:lnSpc>
-                <a:spcPts val="2048"/>
-              </a:lnSpc>
-              <a:spcAft>
-                <a:spcPts val="0"/>
-              </a:spcAft>
-            </a:pPr>
-            <a:r>
-              <a:rPr sz="1600" b="0" i="0">
+                <a:spcPts val="2176"/>
+              </a:lnSpc>
+              <a:spcAft>
+                <a:spcPts val="0"/>
+              </a:spcAft>
+            </a:pPr>
+            <a:r>
+              <a:rPr sz="1700" b="1" i="0">
+                <a:solidFill>
+                  <a:srgbClr val="2D6CB5"/>
+                </a:solidFill>
+                <a:latin typeface="Garamond"/>
+              </a:rPr>
+              <a:t>▪  </a:t>
+            </a:r>
+            <a:r>
+              <a:rPr sz="1700" b="1" i="0">
+                <a:solidFill>
+                  <a:srgbClr val="102D5E"/>
+                </a:solidFill>
+                <a:latin typeface="Garamond"/>
+              </a:rPr>
+              <a:t>Sociodemographics.  </a:t>
+            </a:r>
+            <a:r>
+              <a:rPr sz="1700" b="0" i="0">
                 <a:solidFill>
                   <a:srgbClr val="212529"/>
                 </a:solidFill>
                 <a:latin typeface="Garamond"/>
               </a:rPr>
-              <a:t>Organizational support</a:t>
-            </a:r>
-          </a:p>
-        </p:txBody>
-      </p:sp>
-      <p:sp>
-        <p:nvSpPr>
-          <p:cNvPr id="11" name="TextBox 10"/>
-          <p:cNvSpPr txBox="1"/>
-          <p:nvPr/>
-        </p:nvSpPr>
-        <p:spPr>
-          <a:xfrm>
-            <a:off x="7955279" y="2724912"/>
-            <a:ext cx="3108960" cy="420624"/>
-          </a:xfrm>
-          <a:prstGeom prst="rect">
-            <a:avLst/>
-          </a:prstGeom>
-          <a:noFill/>
-        </p:spPr>
-        <p:txBody>
-          <a:bodyPr wrap="square" lIns="0" rIns="0" tIns="0" bIns="0">
-            <a:spAutoFit/>
-          </a:bodyPr>
-          <a:lstStyle/>
-          <a:p>
-            <a:pPr algn="l">
-              <a:lnSpc>
-                <a:spcPts val="2048"/>
-              </a:lnSpc>
-              <a:spcAft>
-                <a:spcPts val="0"/>
-              </a:spcAft>
-            </a:pPr>
-            <a:r>
-              <a:rPr sz="1600" b="0" i="0">
-                <a:solidFill>
-                  <a:srgbClr val="6B7480"/>
-                </a:solidFill>
-                <a:latin typeface="Garamond"/>
-              </a:rPr>
-              <a:t>no</a:t>
-            </a:r>
-          </a:p>
-        </p:txBody>
-      </p:sp>
-      <p:sp>
-        <p:nvSpPr>
-          <p:cNvPr id="12" name="TextBox 11"/>
-          <p:cNvSpPr txBox="1"/>
-          <p:nvPr/>
-        </p:nvSpPr>
-        <p:spPr>
-          <a:xfrm>
-            <a:off x="822960" y="3145536"/>
-            <a:ext cx="6949440" cy="420624"/>
-          </a:xfrm>
-          <a:prstGeom prst="rect">
-            <a:avLst/>
-          </a:prstGeom>
-          <a:noFill/>
-        </p:spPr>
-        <p:txBody>
-          <a:bodyPr wrap="square" lIns="0" rIns="0" tIns="0" bIns="0">
-            <a:spAutoFit/>
-          </a:bodyPr>
-          <a:lstStyle/>
-          <a:p>
-            <a:pPr algn="l">
-              <a:lnSpc>
-                <a:spcPts val="2048"/>
-              </a:lnSpc>
-              <a:spcAft>
-                <a:spcPts val="0"/>
-              </a:spcAft>
-            </a:pPr>
-            <a:r>
-              <a:rPr sz="1600" b="0" i="0">
-                <a:solidFill>
-                  <a:srgbClr val="212529"/>
-                </a:solidFill>
-                <a:latin typeface="Garamond"/>
-              </a:rPr>
-              <a:t>Autonomy and intrinsic motives</a:t>
-            </a:r>
-          </a:p>
-        </p:txBody>
-      </p:sp>
-      <p:sp>
-        <p:nvSpPr>
-          <p:cNvPr id="13" name="TextBox 12"/>
-          <p:cNvSpPr txBox="1"/>
-          <p:nvPr/>
-        </p:nvSpPr>
-        <p:spPr>
-          <a:xfrm>
-            <a:off x="7955279" y="3145536"/>
-            <a:ext cx="3108960" cy="420624"/>
-          </a:xfrm>
-          <a:prstGeom prst="rect">
-            <a:avLst/>
-          </a:prstGeom>
-          <a:noFill/>
-        </p:spPr>
-        <p:txBody>
-          <a:bodyPr wrap="square" lIns="0" rIns="0" tIns="0" bIns="0">
-            <a:spAutoFit/>
-          </a:bodyPr>
-          <a:lstStyle/>
-          <a:p>
-            <a:pPr algn="l">
-              <a:lnSpc>
-                <a:spcPts val="2048"/>
-              </a:lnSpc>
-              <a:spcAft>
-                <a:spcPts val="0"/>
-              </a:spcAft>
-            </a:pPr>
-            <a:r>
-              <a:rPr sz="1600" b="0" i="0">
-                <a:solidFill>
-                  <a:srgbClr val="6B7480"/>
-                </a:solidFill>
-                <a:latin typeface="Garamond"/>
-              </a:rPr>
-              <a:t>no</a:t>
-            </a:r>
-          </a:p>
-        </p:txBody>
-      </p:sp>
-      <p:sp>
-        <p:nvSpPr>
-          <p:cNvPr id="14" name="TextBox 13"/>
-          <p:cNvSpPr txBox="1"/>
-          <p:nvPr/>
-        </p:nvSpPr>
-        <p:spPr>
-          <a:xfrm>
-            <a:off x="822960" y="3566160"/>
-            <a:ext cx="6949440" cy="420624"/>
-          </a:xfrm>
-          <a:prstGeom prst="rect">
-            <a:avLst/>
-          </a:prstGeom>
-          <a:noFill/>
-        </p:spPr>
-        <p:txBody>
-          <a:bodyPr wrap="square" lIns="0" rIns="0" tIns="0" bIns="0">
-            <a:spAutoFit/>
-          </a:bodyPr>
-          <a:lstStyle/>
-          <a:p>
-            <a:pPr algn="l">
-              <a:lnSpc>
-                <a:spcPts val="2048"/>
-              </a:lnSpc>
-              <a:spcAft>
-                <a:spcPts val="0"/>
-              </a:spcAft>
-            </a:pPr>
-            <a:r>
-              <a:rPr sz="1600" b="0" i="0">
-                <a:solidFill>
-                  <a:srgbClr val="212529"/>
-                </a:solidFill>
-                <a:latin typeface="Garamond"/>
-              </a:rPr>
-              <a:t>Financial factors</a:t>
-            </a:r>
-          </a:p>
-        </p:txBody>
-      </p:sp>
-      <p:sp>
-        <p:nvSpPr>
-          <p:cNvPr id="15" name="TextBox 14"/>
-          <p:cNvSpPr txBox="1"/>
-          <p:nvPr/>
-        </p:nvSpPr>
-        <p:spPr>
-          <a:xfrm>
-            <a:off x="7955279" y="3566160"/>
-            <a:ext cx="3108960" cy="420624"/>
-          </a:xfrm>
-          <a:prstGeom prst="rect">
-            <a:avLst/>
-          </a:prstGeom>
-          <a:noFill/>
-        </p:spPr>
-        <p:txBody>
-          <a:bodyPr wrap="square" lIns="0" rIns="0" tIns="0" bIns="0">
-            <a:spAutoFit/>
-          </a:bodyPr>
-          <a:lstStyle/>
-          <a:p>
-            <a:pPr algn="l">
-              <a:lnSpc>
-                <a:spcPts val="2048"/>
-              </a:lnSpc>
-              <a:spcAft>
-                <a:spcPts val="0"/>
-              </a:spcAft>
-            </a:pPr>
-            <a:r>
-              <a:rPr sz="1600" b="1" i="0">
-                <a:solidFill>
-                  <a:srgbClr val="102D5E"/>
-                </a:solidFill>
-                <a:latin typeface="Garamond"/>
-              </a:rPr>
-              <a:t>yes</a:t>
-            </a:r>
-          </a:p>
-        </p:txBody>
-      </p:sp>
-      <p:sp>
-        <p:nvSpPr>
-          <p:cNvPr id="16" name="TextBox 15"/>
-          <p:cNvSpPr txBox="1"/>
-          <p:nvPr/>
-        </p:nvSpPr>
-        <p:spPr>
-          <a:xfrm>
-            <a:off x="822960" y="3986784"/>
-            <a:ext cx="6949440" cy="420624"/>
-          </a:xfrm>
-          <a:prstGeom prst="rect">
-            <a:avLst/>
-          </a:prstGeom>
-          <a:noFill/>
-        </p:spPr>
-        <p:txBody>
-          <a:bodyPr wrap="square" lIns="0" rIns="0" tIns="0" bIns="0">
-            <a:spAutoFit/>
-          </a:bodyPr>
-          <a:lstStyle/>
-          <a:p>
-            <a:pPr algn="l">
-              <a:lnSpc>
-                <a:spcPts val="2048"/>
-              </a:lnSpc>
-              <a:spcAft>
-                <a:spcPts val="0"/>
-              </a:spcAft>
-            </a:pPr>
-            <a:r>
-              <a:rPr sz="1600" b="0" i="0">
-                <a:solidFill>
-                  <a:srgbClr val="212529"/>
-                </a:solidFill>
-                <a:latin typeface="Garamond"/>
-              </a:rPr>
-              <a:t>Personal life-cycle motives</a:t>
-            </a:r>
-          </a:p>
-        </p:txBody>
-      </p:sp>
-      <p:sp>
-        <p:nvSpPr>
-          <p:cNvPr id="17" name="TextBox 16"/>
-          <p:cNvSpPr txBox="1"/>
-          <p:nvPr/>
-        </p:nvSpPr>
-        <p:spPr>
-          <a:xfrm>
-            <a:off x="7955279" y="3986784"/>
-            <a:ext cx="3108960" cy="420624"/>
-          </a:xfrm>
-          <a:prstGeom prst="rect">
-            <a:avLst/>
-          </a:prstGeom>
-          <a:noFill/>
-        </p:spPr>
-        <p:txBody>
-          <a:bodyPr wrap="square" lIns="0" rIns="0" tIns="0" bIns="0">
-            <a:spAutoFit/>
-          </a:bodyPr>
-          <a:lstStyle/>
-          <a:p>
-            <a:pPr algn="l">
-              <a:lnSpc>
-                <a:spcPts val="2048"/>
-              </a:lnSpc>
-              <a:spcAft>
-                <a:spcPts val="0"/>
-              </a:spcAft>
-            </a:pPr>
-            <a:r>
-              <a:rPr sz="1600" b="1" i="0">
-                <a:solidFill>
-                  <a:srgbClr val="102D5E"/>
-                </a:solidFill>
-                <a:latin typeface="Garamond"/>
-              </a:rPr>
-              <a:t>yes</a:t>
-            </a:r>
-          </a:p>
-        </p:txBody>
-      </p:sp>
-      <p:cxnSp>
-        <p:nvCxnSpPr>
-          <p:cNvPr id="18" name="Connector 17"/>
-          <p:cNvCxnSpPr/>
-          <p:nvPr/>
-        </p:nvCxnSpPr>
-        <p:spPr>
-          <a:xfrm>
-            <a:off x="822960" y="4425696"/>
-            <a:ext cx="10241280" cy="0"/>
-          </a:xfrm>
-          <a:prstGeom prst="line">
-            <a:avLst/>
-          </a:prstGeom>
-          <a:ln w="8890">
-            <a:solidFill>
-              <a:srgbClr val="212529"/>
-            </a:solidFill>
-          </a:ln>
-          <a:effectLst/>
-        </p:spPr>
-        <p:style>
-          <a:lnRef idx="2">
-            <a:schemeClr val="accent1"/>
-          </a:lnRef>
-          <a:fillRef idx="0">
-            <a:schemeClr val="accent1"/>
-          </a:fillRef>
-          <a:effectRef idx="1">
-            <a:schemeClr val="accent1"/>
-          </a:effectRef>
-          <a:fontRef idx="minor">
-            <a:schemeClr val="tx1"/>
-          </a:fontRef>
-        </p:style>
-      </p:cxnSp>
-      <p:sp>
-        <p:nvSpPr>
-          <p:cNvPr id="19" name="TextBox 18"/>
-          <p:cNvSpPr txBox="1"/>
-          <p:nvPr/>
-        </p:nvSpPr>
-        <p:spPr>
-          <a:xfrm>
-            <a:off x="822960" y="4535424"/>
-            <a:ext cx="6949440" cy="420624"/>
-          </a:xfrm>
-          <a:prstGeom prst="rect">
-            <a:avLst/>
-          </a:prstGeom>
-          <a:noFill/>
-        </p:spPr>
-        <p:txBody>
-          <a:bodyPr wrap="square" lIns="0" rIns="0" tIns="0" bIns="0">
-            <a:spAutoFit/>
-          </a:bodyPr>
-          <a:lstStyle/>
-          <a:p>
-            <a:pPr algn="l">
-              <a:lnSpc>
-                <a:spcPts val="2048"/>
-              </a:lnSpc>
-              <a:spcAft>
-                <a:spcPts val="0"/>
-              </a:spcAft>
-            </a:pPr>
-            <a:r>
-              <a:rPr sz="1600" b="0" i="0">
-                <a:solidFill>
-                  <a:srgbClr val="212529"/>
-                </a:solidFill>
-                <a:latin typeface="Garamond"/>
-              </a:rPr>
-              <a:t>Sociodemographics</a:t>
-            </a:r>
-          </a:p>
-        </p:txBody>
-      </p:sp>
-      <p:sp>
-        <p:nvSpPr>
-          <p:cNvPr id="20" name="TextBox 19"/>
-          <p:cNvSpPr txBox="1"/>
-          <p:nvPr/>
-        </p:nvSpPr>
-        <p:spPr>
-          <a:xfrm>
-            <a:off x="7955279" y="4535424"/>
-            <a:ext cx="3108960" cy="420624"/>
-          </a:xfrm>
-          <a:prstGeom prst="rect">
-            <a:avLst/>
-          </a:prstGeom>
-          <a:noFill/>
-        </p:spPr>
-        <p:txBody>
-          <a:bodyPr wrap="square" lIns="0" rIns="0" tIns="0" bIns="0">
-            <a:spAutoFit/>
-          </a:bodyPr>
-          <a:lstStyle/>
-          <a:p>
-            <a:pPr algn="l">
-              <a:lnSpc>
-                <a:spcPts val="2048"/>
-              </a:lnSpc>
-              <a:spcAft>
-                <a:spcPts val="0"/>
-              </a:spcAft>
-            </a:pPr>
-            <a:r>
-              <a:rPr sz="1600" b="1" i="0">
-                <a:solidFill>
-                  <a:srgbClr val="102D5E"/>
-                </a:solidFill>
-                <a:latin typeface="Garamond"/>
-              </a:rPr>
-              <a:t>yes</a:t>
-            </a:r>
-          </a:p>
-        </p:txBody>
-      </p:sp>
-      <p:cxnSp>
-        <p:nvCxnSpPr>
-          <p:cNvPr id="21" name="Connector 20"/>
-          <p:cNvCxnSpPr/>
-          <p:nvPr/>
-        </p:nvCxnSpPr>
-        <p:spPr>
-          <a:xfrm>
-            <a:off x="822960" y="4992624"/>
-            <a:ext cx="10241280" cy="0"/>
-          </a:xfrm>
-          <a:prstGeom prst="line">
-            <a:avLst/>
-          </a:prstGeom>
-          <a:ln w="16510">
-            <a:solidFill>
-              <a:srgbClr val="212529"/>
-            </a:solidFill>
-          </a:ln>
-          <a:effectLst/>
-        </p:spPr>
-        <p:style>
-          <a:lnRef idx="2">
-            <a:schemeClr val="accent1"/>
-          </a:lnRef>
-          <a:fillRef idx="0">
-            <a:schemeClr val="accent1"/>
-          </a:fillRef>
-          <a:effectRef idx="1">
-            <a:schemeClr val="accent1"/>
-          </a:effectRef>
-          <a:fontRef idx="minor">
-            <a:schemeClr val="tx1"/>
-          </a:fontRef>
-        </p:style>
-      </p:cxnSp>
-      <p:sp>
-        <p:nvSpPr>
-          <p:cNvPr id="22" name="Rounded Rectangle 21">
+              <a:t>Sex, age, education, race and ethnicity, and state.</a:t>
+            </a:r>
+          </a:p>
+        </p:txBody>
+      </p:sp>
+      <p:sp>
+        <p:nvSpPr>
+          <p:cNvPr id="9" name="Rounded Rectangle 8">
             <a:hlinkClick action="ppaction://hlinksldjump" r:id="rId2"/>
           </p:cNvPr>
           <p:cNvSpPr/>

</xml_diff>